<commit_message>
diplomski rad i prezentacija
</commit_message>
<xml_diff>
--- a/Prezentacija_Diplomski_Boris_Letic_RA_207_2021.pptx
+++ b/Prezentacija_Diplomski_Boris_Letic_RA_207_2021.pptx
@@ -176,10 +176,9 @@
           <a:lstStyle/>
           <a:p>
             <a:r>
-              <a:rPr lang="en-US" smtClean="0"/>
+              <a:rPr lang="en-US"/>
               <a:t>Click to edit Master title style</a:t>
             </a:r>
-            <a:endParaRPr lang="en-US"/>
           </a:p>
         </p:txBody>
       </p:sp>
@@ -295,10 +294,9 @@
           </a:lstStyle>
           <a:p>
             <a:r>
-              <a:rPr lang="en-US" smtClean="0"/>
+              <a:rPr lang="en-US"/>
               <a:t>Click to edit Master subtitle style</a:t>
             </a:r>
-            <a:endParaRPr lang="en-US"/>
           </a:p>
         </p:txBody>
       </p:sp>
@@ -319,7 +317,7 @@
           <a:p>
             <a:fld id="{5BCAD085-E8A6-8845-BD4E-CB4CCA059FC4}" type="datetimeFigureOut">
               <a:rPr lang="en-US" smtClean="0"/>
-              <a:t>11/15/2025</a:t>
+              <a:t>11/23/2025</a:t>
             </a:fld>
             <a:endParaRPr lang="en-US"/>
           </a:p>
@@ -413,10 +411,9 @@
           <a:lstStyle/>
           <a:p>
             <a:r>
-              <a:rPr lang="en-US" smtClean="0"/>
+              <a:rPr lang="en-US"/>
               <a:t>Click to edit Master title style</a:t>
             </a:r>
-            <a:endParaRPr lang="en-US"/>
           </a:p>
         </p:txBody>
       </p:sp>
@@ -437,38 +434,37 @@
           <a:p>
             <a:pPr lvl="0"/>
             <a:r>
-              <a:rPr lang="en-US" smtClean="0"/>
+              <a:rPr lang="en-US"/>
               <a:t>Click to edit Master text styles</a:t>
             </a:r>
           </a:p>
           <a:p>
             <a:pPr lvl="1"/>
             <a:r>
-              <a:rPr lang="en-US" smtClean="0"/>
+              <a:rPr lang="en-US"/>
               <a:t>Second level</a:t>
             </a:r>
           </a:p>
           <a:p>
             <a:pPr lvl="2"/>
             <a:r>
-              <a:rPr lang="en-US" smtClean="0"/>
+              <a:rPr lang="en-US"/>
               <a:t>Third level</a:t>
             </a:r>
           </a:p>
           <a:p>
             <a:pPr lvl="3"/>
             <a:r>
-              <a:rPr lang="en-US" smtClean="0"/>
+              <a:rPr lang="en-US"/>
               <a:t>Fourth level</a:t>
             </a:r>
           </a:p>
           <a:p>
             <a:pPr lvl="4"/>
             <a:r>
-              <a:rPr lang="en-US" smtClean="0"/>
+              <a:rPr lang="en-US"/>
               <a:t>Fifth level</a:t>
             </a:r>
-            <a:endParaRPr lang="en-US"/>
           </a:p>
         </p:txBody>
       </p:sp>
@@ -489,7 +485,7 @@
           <a:p>
             <a:fld id="{5BCAD085-E8A6-8845-BD4E-CB4CCA059FC4}" type="datetimeFigureOut">
               <a:rPr lang="en-US" smtClean="0"/>
-              <a:t>11/15/2025</a:t>
+              <a:t>11/23/2025</a:t>
             </a:fld>
             <a:endParaRPr lang="en-US"/>
           </a:p>
@@ -588,10 +584,9 @@
           <a:lstStyle/>
           <a:p>
             <a:r>
-              <a:rPr lang="en-US" smtClean="0"/>
+              <a:rPr lang="en-US"/>
               <a:t>Click to edit Master title style</a:t>
             </a:r>
-            <a:endParaRPr lang="en-US"/>
           </a:p>
         </p:txBody>
       </p:sp>
@@ -617,38 +612,37 @@
           <a:p>
             <a:pPr lvl="0"/>
             <a:r>
-              <a:rPr lang="en-US" smtClean="0"/>
+              <a:rPr lang="en-US"/>
               <a:t>Click to edit Master text styles</a:t>
             </a:r>
           </a:p>
           <a:p>
             <a:pPr lvl="1"/>
             <a:r>
-              <a:rPr lang="en-US" smtClean="0"/>
+              <a:rPr lang="en-US"/>
               <a:t>Second level</a:t>
             </a:r>
           </a:p>
           <a:p>
             <a:pPr lvl="2"/>
             <a:r>
-              <a:rPr lang="en-US" smtClean="0"/>
+              <a:rPr lang="en-US"/>
               <a:t>Third level</a:t>
             </a:r>
           </a:p>
           <a:p>
             <a:pPr lvl="3"/>
             <a:r>
-              <a:rPr lang="en-US" smtClean="0"/>
+              <a:rPr lang="en-US"/>
               <a:t>Fourth level</a:t>
             </a:r>
           </a:p>
           <a:p>
             <a:pPr lvl="4"/>
             <a:r>
-              <a:rPr lang="en-US" smtClean="0"/>
+              <a:rPr lang="en-US"/>
               <a:t>Fifth level</a:t>
             </a:r>
-            <a:endParaRPr lang="en-US"/>
           </a:p>
         </p:txBody>
       </p:sp>
@@ -669,7 +663,7 @@
           <a:p>
             <a:fld id="{5BCAD085-E8A6-8845-BD4E-CB4CCA059FC4}" type="datetimeFigureOut">
               <a:rPr lang="en-US" smtClean="0"/>
-              <a:t>11/15/2025</a:t>
+              <a:t>11/23/2025</a:t>
             </a:fld>
             <a:endParaRPr lang="en-US"/>
           </a:p>
@@ -763,10 +757,9 @@
           <a:lstStyle/>
           <a:p>
             <a:r>
-              <a:rPr lang="en-US" smtClean="0"/>
+              <a:rPr lang="en-US"/>
               <a:t>Click to edit Master title style</a:t>
             </a:r>
-            <a:endParaRPr lang="en-US"/>
           </a:p>
         </p:txBody>
       </p:sp>
@@ -787,38 +780,37 @@
           <a:p>
             <a:pPr lvl="0"/>
             <a:r>
-              <a:rPr lang="en-US" smtClean="0"/>
+              <a:rPr lang="en-US"/>
               <a:t>Click to edit Master text styles</a:t>
             </a:r>
           </a:p>
           <a:p>
             <a:pPr lvl="1"/>
             <a:r>
-              <a:rPr lang="en-US" smtClean="0"/>
+              <a:rPr lang="en-US"/>
               <a:t>Second level</a:t>
             </a:r>
           </a:p>
           <a:p>
             <a:pPr lvl="2"/>
             <a:r>
-              <a:rPr lang="en-US" smtClean="0"/>
+              <a:rPr lang="en-US"/>
               <a:t>Third level</a:t>
             </a:r>
           </a:p>
           <a:p>
             <a:pPr lvl="3"/>
             <a:r>
-              <a:rPr lang="en-US" smtClean="0"/>
+              <a:rPr lang="en-US"/>
               <a:t>Fourth level</a:t>
             </a:r>
           </a:p>
           <a:p>
             <a:pPr lvl="4"/>
             <a:r>
-              <a:rPr lang="en-US" smtClean="0"/>
+              <a:rPr lang="en-US"/>
               <a:t>Fifth level</a:t>
             </a:r>
-            <a:endParaRPr lang="en-US"/>
           </a:p>
         </p:txBody>
       </p:sp>
@@ -839,7 +831,7 @@
           <a:p>
             <a:fld id="{5BCAD085-E8A6-8845-BD4E-CB4CCA059FC4}" type="datetimeFigureOut">
               <a:rPr lang="en-US" smtClean="0"/>
-              <a:t>11/15/2025</a:t>
+              <a:t>11/23/2025</a:t>
             </a:fld>
             <a:endParaRPr lang="en-US"/>
           </a:p>
@@ -942,10 +934,9 @@
           </a:lstStyle>
           <a:p>
             <a:r>
-              <a:rPr lang="en-US" smtClean="0"/>
+              <a:rPr lang="en-US"/>
               <a:t>Click to edit Master title style</a:t>
             </a:r>
-            <a:endParaRPr lang="en-US"/>
           </a:p>
         </p:txBody>
       </p:sp>
@@ -1062,7 +1053,7 @@
           <a:p>
             <a:pPr lvl="0"/>
             <a:r>
-              <a:rPr lang="en-US" smtClean="0"/>
+              <a:rPr lang="en-US"/>
               <a:t>Click to edit Master text styles</a:t>
             </a:r>
           </a:p>
@@ -1085,7 +1076,7 @@
           <a:p>
             <a:fld id="{5BCAD085-E8A6-8845-BD4E-CB4CCA059FC4}" type="datetimeFigureOut">
               <a:rPr lang="en-US" smtClean="0"/>
-              <a:t>11/15/2025</a:t>
+              <a:t>11/23/2025</a:t>
             </a:fld>
             <a:endParaRPr lang="en-US"/>
           </a:p>
@@ -1179,10 +1170,9 @@
           <a:lstStyle/>
           <a:p>
             <a:r>
-              <a:rPr lang="en-US" smtClean="0"/>
+              <a:rPr lang="en-US"/>
               <a:t>Click to edit Master title style</a:t>
             </a:r>
-            <a:endParaRPr lang="en-US"/>
           </a:p>
         </p:txBody>
       </p:sp>
@@ -1236,38 +1226,37 @@
           <a:p>
             <a:pPr lvl="0"/>
             <a:r>
-              <a:rPr lang="en-US" smtClean="0"/>
+              <a:rPr lang="en-US"/>
               <a:t>Click to edit Master text styles</a:t>
             </a:r>
           </a:p>
           <a:p>
             <a:pPr lvl="1"/>
             <a:r>
-              <a:rPr lang="en-US" smtClean="0"/>
+              <a:rPr lang="en-US"/>
               <a:t>Second level</a:t>
             </a:r>
           </a:p>
           <a:p>
             <a:pPr lvl="2"/>
             <a:r>
-              <a:rPr lang="en-US" smtClean="0"/>
+              <a:rPr lang="en-US"/>
               <a:t>Third level</a:t>
             </a:r>
           </a:p>
           <a:p>
             <a:pPr lvl="3"/>
             <a:r>
-              <a:rPr lang="en-US" smtClean="0"/>
+              <a:rPr lang="en-US"/>
               <a:t>Fourth level</a:t>
             </a:r>
           </a:p>
           <a:p>
             <a:pPr lvl="4"/>
             <a:r>
-              <a:rPr lang="en-US" smtClean="0"/>
+              <a:rPr lang="en-US"/>
               <a:t>Fifth level</a:t>
             </a:r>
-            <a:endParaRPr lang="en-US"/>
           </a:p>
         </p:txBody>
       </p:sp>
@@ -1321,38 +1310,37 @@
           <a:p>
             <a:pPr lvl="0"/>
             <a:r>
-              <a:rPr lang="en-US" smtClean="0"/>
+              <a:rPr lang="en-US"/>
               <a:t>Click to edit Master text styles</a:t>
             </a:r>
           </a:p>
           <a:p>
             <a:pPr lvl="1"/>
             <a:r>
-              <a:rPr lang="en-US" smtClean="0"/>
+              <a:rPr lang="en-US"/>
               <a:t>Second level</a:t>
             </a:r>
           </a:p>
           <a:p>
             <a:pPr lvl="2"/>
             <a:r>
-              <a:rPr lang="en-US" smtClean="0"/>
+              <a:rPr lang="en-US"/>
               <a:t>Third level</a:t>
             </a:r>
           </a:p>
           <a:p>
             <a:pPr lvl="3"/>
             <a:r>
-              <a:rPr lang="en-US" smtClean="0"/>
+              <a:rPr lang="en-US"/>
               <a:t>Fourth level</a:t>
             </a:r>
           </a:p>
           <a:p>
             <a:pPr lvl="4"/>
             <a:r>
-              <a:rPr lang="en-US" smtClean="0"/>
+              <a:rPr lang="en-US"/>
               <a:t>Fifth level</a:t>
             </a:r>
-            <a:endParaRPr lang="en-US"/>
           </a:p>
         </p:txBody>
       </p:sp>
@@ -1373,7 +1361,7 @@
           <a:p>
             <a:fld id="{5BCAD085-E8A6-8845-BD4E-CB4CCA059FC4}" type="datetimeFigureOut">
               <a:rPr lang="en-US" smtClean="0"/>
-              <a:t>11/15/2025</a:t>
+              <a:t>11/23/2025</a:t>
             </a:fld>
             <a:endParaRPr lang="en-US"/>
           </a:p>
@@ -1471,10 +1459,9 @@
           </a:lstStyle>
           <a:p>
             <a:r>
-              <a:rPr lang="en-US" smtClean="0"/>
+              <a:rPr lang="en-US"/>
               <a:t>Click to edit Master title style</a:t>
             </a:r>
-            <a:endParaRPr lang="en-US"/>
           </a:p>
         </p:txBody>
       </p:sp>
@@ -1537,7 +1524,7 @@
           <a:p>
             <a:pPr lvl="0"/>
             <a:r>
-              <a:rPr lang="en-US" smtClean="0"/>
+              <a:rPr lang="en-US"/>
               <a:t>Click to edit Master text styles</a:t>
             </a:r>
           </a:p>
@@ -1593,38 +1580,37 @@
           <a:p>
             <a:pPr lvl="0"/>
             <a:r>
-              <a:rPr lang="en-US" smtClean="0"/>
+              <a:rPr lang="en-US"/>
               <a:t>Click to edit Master text styles</a:t>
             </a:r>
           </a:p>
           <a:p>
             <a:pPr lvl="1"/>
             <a:r>
-              <a:rPr lang="en-US" smtClean="0"/>
+              <a:rPr lang="en-US"/>
               <a:t>Second level</a:t>
             </a:r>
           </a:p>
           <a:p>
             <a:pPr lvl="2"/>
             <a:r>
-              <a:rPr lang="en-US" smtClean="0"/>
+              <a:rPr lang="en-US"/>
               <a:t>Third level</a:t>
             </a:r>
           </a:p>
           <a:p>
             <a:pPr lvl="3"/>
             <a:r>
-              <a:rPr lang="en-US" smtClean="0"/>
+              <a:rPr lang="en-US"/>
               <a:t>Fourth level</a:t>
             </a:r>
           </a:p>
           <a:p>
             <a:pPr lvl="4"/>
             <a:r>
-              <a:rPr lang="en-US" smtClean="0"/>
+              <a:rPr lang="en-US"/>
               <a:t>Fifth level</a:t>
             </a:r>
-            <a:endParaRPr lang="en-US"/>
           </a:p>
         </p:txBody>
       </p:sp>
@@ -1687,7 +1673,7 @@
           <a:p>
             <a:pPr lvl="0"/>
             <a:r>
-              <a:rPr lang="en-US" smtClean="0"/>
+              <a:rPr lang="en-US"/>
               <a:t>Click to edit Master text styles</a:t>
             </a:r>
           </a:p>
@@ -1743,38 +1729,37 @@
           <a:p>
             <a:pPr lvl="0"/>
             <a:r>
-              <a:rPr lang="en-US" smtClean="0"/>
+              <a:rPr lang="en-US"/>
               <a:t>Click to edit Master text styles</a:t>
             </a:r>
           </a:p>
           <a:p>
             <a:pPr lvl="1"/>
             <a:r>
-              <a:rPr lang="en-US" smtClean="0"/>
+              <a:rPr lang="en-US"/>
               <a:t>Second level</a:t>
             </a:r>
           </a:p>
           <a:p>
             <a:pPr lvl="2"/>
             <a:r>
-              <a:rPr lang="en-US" smtClean="0"/>
+              <a:rPr lang="en-US"/>
               <a:t>Third level</a:t>
             </a:r>
           </a:p>
           <a:p>
             <a:pPr lvl="3"/>
             <a:r>
-              <a:rPr lang="en-US" smtClean="0"/>
+              <a:rPr lang="en-US"/>
               <a:t>Fourth level</a:t>
             </a:r>
           </a:p>
           <a:p>
             <a:pPr lvl="4"/>
             <a:r>
-              <a:rPr lang="en-US" smtClean="0"/>
+              <a:rPr lang="en-US"/>
               <a:t>Fifth level</a:t>
             </a:r>
-            <a:endParaRPr lang="en-US"/>
           </a:p>
         </p:txBody>
       </p:sp>
@@ -1795,7 +1780,7 @@
           <a:p>
             <a:fld id="{5BCAD085-E8A6-8845-BD4E-CB4CCA059FC4}" type="datetimeFigureOut">
               <a:rPr lang="en-US" smtClean="0"/>
-              <a:t>11/15/2025</a:t>
+              <a:t>11/23/2025</a:t>
             </a:fld>
             <a:endParaRPr lang="en-US"/>
           </a:p>
@@ -1889,10 +1874,9 @@
           <a:lstStyle/>
           <a:p>
             <a:r>
-              <a:rPr lang="en-US" smtClean="0"/>
+              <a:rPr lang="en-US"/>
               <a:t>Click to edit Master title style</a:t>
             </a:r>
-            <a:endParaRPr lang="en-US"/>
           </a:p>
         </p:txBody>
       </p:sp>
@@ -1913,7 +1897,7 @@
           <a:p>
             <a:fld id="{5BCAD085-E8A6-8845-BD4E-CB4CCA059FC4}" type="datetimeFigureOut">
               <a:rPr lang="en-US" smtClean="0"/>
-              <a:t>11/15/2025</a:t>
+              <a:t>11/23/2025</a:t>
             </a:fld>
             <a:endParaRPr lang="en-US"/>
           </a:p>
@@ -2008,7 +1992,7 @@
           <a:p>
             <a:fld id="{5BCAD085-E8A6-8845-BD4E-CB4CCA059FC4}" type="datetimeFigureOut">
               <a:rPr lang="en-US" smtClean="0"/>
-              <a:t>11/15/2025</a:t>
+              <a:t>11/23/2025</a:t>
             </a:fld>
             <a:endParaRPr lang="en-US"/>
           </a:p>
@@ -2111,10 +2095,9 @@
           </a:lstStyle>
           <a:p>
             <a:r>
-              <a:rPr lang="en-US" smtClean="0"/>
+              <a:rPr lang="en-US"/>
               <a:t>Click to edit Master title style</a:t>
             </a:r>
-            <a:endParaRPr lang="en-US"/>
           </a:p>
         </p:txBody>
       </p:sp>
@@ -2168,38 +2151,37 @@
           <a:p>
             <a:pPr lvl="0"/>
             <a:r>
-              <a:rPr lang="en-US" smtClean="0"/>
+              <a:rPr lang="en-US"/>
               <a:t>Click to edit Master text styles</a:t>
             </a:r>
           </a:p>
           <a:p>
             <a:pPr lvl="1"/>
             <a:r>
-              <a:rPr lang="en-US" smtClean="0"/>
+              <a:rPr lang="en-US"/>
               <a:t>Second level</a:t>
             </a:r>
           </a:p>
           <a:p>
             <a:pPr lvl="2"/>
             <a:r>
-              <a:rPr lang="en-US" smtClean="0"/>
+              <a:rPr lang="en-US"/>
               <a:t>Third level</a:t>
             </a:r>
           </a:p>
           <a:p>
             <a:pPr lvl="3"/>
             <a:r>
-              <a:rPr lang="en-US" smtClean="0"/>
+              <a:rPr lang="en-US"/>
               <a:t>Fourth level</a:t>
             </a:r>
           </a:p>
           <a:p>
             <a:pPr lvl="4"/>
             <a:r>
-              <a:rPr lang="en-US" smtClean="0"/>
+              <a:rPr lang="en-US"/>
               <a:t>Fifth level</a:t>
             </a:r>
-            <a:endParaRPr lang="en-US"/>
           </a:p>
         </p:txBody>
       </p:sp>
@@ -2262,7 +2244,7 @@
           <a:p>
             <a:pPr lvl="0"/>
             <a:r>
-              <a:rPr lang="en-US" smtClean="0"/>
+              <a:rPr lang="en-US"/>
               <a:t>Click to edit Master text styles</a:t>
             </a:r>
           </a:p>
@@ -2285,7 +2267,7 @@
           <a:p>
             <a:fld id="{5BCAD085-E8A6-8845-BD4E-CB4CCA059FC4}" type="datetimeFigureOut">
               <a:rPr lang="en-US" smtClean="0"/>
-              <a:t>11/15/2025</a:t>
+              <a:t>11/23/2025</a:t>
             </a:fld>
             <a:endParaRPr lang="en-US"/>
           </a:p>
@@ -2388,10 +2370,9 @@
           </a:lstStyle>
           <a:p>
             <a:r>
-              <a:rPr lang="en-US" smtClean="0"/>
+              <a:rPr lang="en-US"/>
               <a:t>Click to edit Master title style</a:t>
             </a:r>
-            <a:endParaRPr lang="en-US"/>
           </a:p>
         </p:txBody>
       </p:sp>
@@ -2515,7 +2496,7 @@
           <a:p>
             <a:pPr lvl="0"/>
             <a:r>
-              <a:rPr lang="en-US" smtClean="0"/>
+              <a:rPr lang="en-US"/>
               <a:t>Click to edit Master text styles</a:t>
             </a:r>
           </a:p>
@@ -2538,7 +2519,7 @@
           <a:p>
             <a:fld id="{5BCAD085-E8A6-8845-BD4E-CB4CCA059FC4}" type="datetimeFigureOut">
               <a:rPr lang="en-US" smtClean="0"/>
-              <a:t>11/15/2025</a:t>
+              <a:t>11/23/2025</a:t>
             </a:fld>
             <a:endParaRPr lang="en-US"/>
           </a:p>
@@ -2647,10 +2628,9 @@
           <a:lstStyle/>
           <a:p>
             <a:r>
-              <a:rPr lang="en-US" smtClean="0"/>
+              <a:rPr lang="en-US"/>
               <a:t>Click to edit Master title style</a:t>
             </a:r>
-            <a:endParaRPr lang="en-US"/>
           </a:p>
         </p:txBody>
       </p:sp>
@@ -2681,38 +2661,37 @@
           <a:p>
             <a:pPr lvl="0"/>
             <a:r>
-              <a:rPr lang="en-US" smtClean="0"/>
+              <a:rPr lang="en-US"/>
               <a:t>Click to edit Master text styles</a:t>
             </a:r>
           </a:p>
           <a:p>
             <a:pPr lvl="1"/>
             <a:r>
-              <a:rPr lang="en-US" smtClean="0"/>
+              <a:rPr lang="en-US"/>
               <a:t>Second level</a:t>
             </a:r>
           </a:p>
           <a:p>
             <a:pPr lvl="2"/>
             <a:r>
-              <a:rPr lang="en-US" smtClean="0"/>
+              <a:rPr lang="en-US"/>
               <a:t>Third level</a:t>
             </a:r>
           </a:p>
           <a:p>
             <a:pPr lvl="3"/>
             <a:r>
-              <a:rPr lang="en-US" smtClean="0"/>
+              <a:rPr lang="en-US"/>
               <a:t>Fourth level</a:t>
             </a:r>
           </a:p>
           <a:p>
             <a:pPr lvl="4"/>
             <a:r>
-              <a:rPr lang="en-US" smtClean="0"/>
+              <a:rPr lang="en-US"/>
               <a:t>Fifth level</a:t>
             </a:r>
-            <a:endParaRPr lang="en-US"/>
           </a:p>
         </p:txBody>
       </p:sp>
@@ -2751,7 +2730,7 @@
           <a:p>
             <a:fld id="{5BCAD085-E8A6-8845-BD4E-CB4CCA059FC4}" type="datetimeFigureOut">
               <a:rPr lang="en-US" smtClean="0"/>
-              <a:t>11/15/2025</a:t>
+              <a:t>11/23/2025</a:t>
             </a:fld>
             <a:endParaRPr lang="en-US"/>
           </a:p>
@@ -3244,7 +3223,7 @@
               </a:defRPr>
             </a:pPr>
             <a:r>
-              <a:rPr lang="sr-Cyrl-RS" sz="3200" b="1" dirty="0" smtClean="0"/>
+              <a:rPr lang="sr-Cyrl-RS" sz="3200" b="1" dirty="0"/>
               <a:t>Анализа сентимента крипто заједнице на друштвеним мрежама помоћу машинског учења</a:t>
             </a:r>
             <a:endParaRPr dirty="0"/>
@@ -3281,7 +3260,7 @@
               </a:defRPr>
             </a:pPr>
             <a:r>
-              <a:rPr lang="sr-Cyrl-RS" sz="3200" dirty="0" smtClean="0">
+              <a:rPr lang="sr-Cyrl-RS" sz="3200" dirty="0">
                 <a:solidFill>
                   <a:srgbClr val="9DD5C8"/>
                 </a:solidFill>
@@ -3319,14 +3298,14 @@
           <a:lstStyle/>
           <a:p>
             <a:r>
-              <a:rPr lang="sr-Cyrl-RS" sz="1900" b="1" dirty="0" smtClean="0">
+              <a:rPr lang="sr-Cyrl-RS" sz="1900" b="1" dirty="0">
                 <a:solidFill>
                   <a:srgbClr val="1C453D"/>
                 </a:solidFill>
               </a:rPr>
               <a:t>Универзитет у Новом Саду</a:t>
             </a:r>
-            <a:endParaRPr lang="en-US" sz="1900" b="1" dirty="0" smtClean="0">
+            <a:endParaRPr lang="en-US" sz="1900" b="1" dirty="0">
               <a:solidFill>
                 <a:srgbClr val="1C453D"/>
               </a:solidFill>
@@ -3334,7 +3313,7 @@
           </a:p>
           <a:p>
             <a:r>
-              <a:rPr lang="sr-Cyrl-RS" sz="1900" b="1" dirty="0" smtClean="0">
+              <a:rPr lang="sr-Cyrl-RS" sz="1900" b="1" dirty="0">
                 <a:solidFill>
                   <a:srgbClr val="1C453D"/>
                 </a:solidFill>
@@ -3379,14 +3358,14 @@
               </a:defRPr>
             </a:pPr>
             <a:r>
-              <a:rPr lang="sr-Cyrl-RS" sz="1900" b="1" dirty="0" smtClean="0">
+              <a:rPr lang="sr-Cyrl-RS" sz="1900" b="1" dirty="0">
                 <a:solidFill>
                   <a:srgbClr val="1C453D"/>
                 </a:solidFill>
               </a:rPr>
               <a:t>Ментор: др Душан Гајић, ванредни професор</a:t>
             </a:r>
-            <a:endParaRPr lang="en-US" sz="1900" b="1" dirty="0" smtClean="0">
+            <a:endParaRPr lang="en-US" sz="1900" b="1" dirty="0">
               <a:solidFill>
                 <a:srgbClr val="1C453D"/>
               </a:solidFill>
@@ -3401,7 +3380,7 @@
               </a:defRPr>
             </a:pPr>
             <a:r>
-              <a:rPr lang="sr-Cyrl-RS" sz="1900" b="1" dirty="0" smtClean="0">
+              <a:rPr lang="sr-Cyrl-RS" sz="1900" b="1" dirty="0">
                 <a:solidFill>
                   <a:srgbClr val="1C453D"/>
                 </a:solidFill>
@@ -3409,7 +3388,7 @@
               <a:t>Кандидат</a:t>
             </a:r>
             <a:r>
-              <a:rPr lang="en-US" sz="1900" b="1" dirty="0" smtClean="0">
+              <a:rPr lang="en-US" sz="1900" b="1" dirty="0">
                 <a:solidFill>
                   <a:srgbClr val="1C453D"/>
                 </a:solidFill>
@@ -3417,7 +3396,7 @@
               <a:t>: </a:t>
             </a:r>
             <a:r>
-              <a:rPr lang="sr-Cyrl-RS" sz="1900" b="1" dirty="0" smtClean="0">
+              <a:rPr lang="sr-Cyrl-RS" sz="1900" b="1" dirty="0">
                 <a:solidFill>
                   <a:srgbClr val="1C453D"/>
                 </a:solidFill>
@@ -3425,7 +3404,7 @@
               <a:t>Борис Летић </a:t>
             </a:r>
             <a:r>
-              <a:rPr lang="en-US" sz="1900" b="1" dirty="0" smtClean="0">
+              <a:rPr lang="en-US" sz="1900" b="1" dirty="0">
                 <a:solidFill>
                   <a:srgbClr val="1C453D"/>
                 </a:solidFill>
@@ -3443,13 +3422,6 @@
   <p:clrMapOvr>
     <a:masterClrMapping/>
   </p:clrMapOvr>
-  <p:timing>
-    <p:tnLst>
-      <p:par>
-        <p:cTn id="1" dur="indefinite" restart="never" nodeType="tmRoot"/>
-      </p:par>
-    </p:tnLst>
-  </p:timing>
 </p:sld>
 </file>
 
@@ -3720,7 +3692,7 @@
               </a:defRPr>
             </a:pPr>
             <a:r>
-              <a:rPr lang="sr-Cyrl-RS" dirty="0" smtClean="0"/>
+              <a:rPr lang="sr-Cyrl-RS" dirty="0"/>
               <a:t>Резултати – перформансе модела</a:t>
             </a:r>
             <a:endParaRPr dirty="0"/>
@@ -3757,7 +3729,7 @@
               </a:defRPr>
             </a:pPr>
             <a:r>
-              <a:rPr lang="sr-Cyrl-RS" dirty="0" smtClean="0">
+              <a:rPr lang="sr-Cyrl-RS" dirty="0">
                 <a:solidFill>
                   <a:srgbClr val="1C453D"/>
                 </a:solidFill>
@@ -3802,7 +3774,7 @@
               </a:defRPr>
             </a:pPr>
             <a:r>
-              <a:rPr lang="sr-Cyrl-RS" dirty="0" smtClean="0">
+              <a:rPr lang="sr-Cyrl-RS" dirty="0">
                 <a:solidFill>
                   <a:srgbClr val="1C453D"/>
                 </a:solidFill>
@@ -3887,7 +3859,7 @@
               </a:defRPr>
             </a:pPr>
             <a:r>
-              <a:rPr lang="sr-Cyrl-RS" dirty="0" smtClean="0">
+              <a:rPr lang="sr-Cyrl-RS" dirty="0">
                 <a:solidFill>
                   <a:srgbClr val="1C453D"/>
                 </a:solidFill>
@@ -4041,7 +4013,7 @@
               <a:t>~10 </a:t>
             </a:r>
             <a:r>
-              <a:rPr lang="sr-Cyrl-RS" dirty="0" smtClean="0"/>
+              <a:rPr lang="sr-Cyrl-RS" dirty="0"/>
               <a:t>секунди</a:t>
             </a:r>
             <a:endParaRPr dirty="0"/>
@@ -4187,7 +4159,7 @@
               <a:t>~45 </a:t>
             </a:r>
             <a:r>
-              <a:rPr lang="sr-Cyrl-RS" dirty="0" smtClean="0"/>
+              <a:rPr lang="sr-Cyrl-RS" dirty="0"/>
               <a:t>секунди</a:t>
             </a:r>
             <a:endParaRPr dirty="0"/>
@@ -4333,16 +4305,12 @@
               <a:t>~15 </a:t>
             </a:r>
             <a:r>
-              <a:rPr lang="sr-Cyrl-RS" dirty="0" smtClean="0"/>
+              <a:rPr lang="sr-Cyrl-RS" dirty="0"/>
               <a:t>минута</a:t>
             </a:r>
             <a:r>
-              <a:rPr dirty="0" smtClean="0"/>
-              <a:t> </a:t>
-            </a:r>
-            <a:r>
-              <a:rPr dirty="0"/>
-              <a:t>(GPU)</a:t>
+              <a:rPr dirty="0"/>
+              <a:t> (GPU)</a:t>
             </a:r>
           </a:p>
         </p:txBody>
@@ -4424,40 +4392,32 @@
               </a:defRPr>
             </a:pPr>
             <a:r>
-              <a:rPr dirty="0" smtClean="0"/>
+              <a:rPr dirty="0"/>
               <a:t>SVM </a:t>
             </a:r>
             <a:r>
-              <a:rPr lang="sr-Cyrl-RS" dirty="0" smtClean="0"/>
+              <a:rPr lang="sr-Cyrl-RS" dirty="0"/>
               <a:t>постигао најбоље резултате </a:t>
             </a:r>
             <a:r>
-              <a:rPr dirty="0" smtClean="0"/>
-              <a:t>(95.24</a:t>
-            </a:r>
-            <a:r>
-              <a:rPr dirty="0"/>
-              <a:t>%), </a:t>
-            </a:r>
-            <a:r>
-              <a:rPr lang="sr-Cyrl-RS" dirty="0" smtClean="0"/>
+              <a:rPr dirty="0"/>
+              <a:t>(95.24%), </a:t>
+            </a:r>
+            <a:r>
+              <a:rPr lang="sr-Cyrl-RS" dirty="0"/>
               <a:t>док је </a:t>
             </a:r>
             <a:r>
-              <a:rPr dirty="0" smtClean="0"/>
+              <a:rPr dirty="0"/>
               <a:t>BERT </a:t>
             </a:r>
             <a:r>
-              <a:rPr lang="sr-Cyrl-RS" dirty="0" smtClean="0"/>
+              <a:rPr lang="sr-Cyrl-RS" dirty="0"/>
               <a:t>био други са </a:t>
             </a:r>
             <a:r>
-              <a:rPr dirty="0" smtClean="0"/>
-              <a:t>94.84</a:t>
-            </a:r>
-            <a:r>
-              <a:rPr dirty="0"/>
-              <a:t>%.</a:t>
+              <a:rPr dirty="0"/>
+              <a:t>94.84%.</a:t>
             </a:r>
             <a:br>
               <a:rPr dirty="0"/>
@@ -4467,24 +4427,20 @@
               <a:t>Naive Bayes </a:t>
             </a:r>
             <a:r>
-              <a:rPr lang="sr-Cyrl-RS" dirty="0" smtClean="0"/>
+              <a:rPr lang="sr-Cyrl-RS" dirty="0"/>
               <a:t>показао солидне </a:t>
             </a:r>
             <a:r>
-              <a:rPr dirty="0" smtClean="0"/>
+              <a:rPr dirty="0"/>
               <a:t>baseline </a:t>
             </a:r>
             <a:r>
-              <a:rPr lang="sr-Cyrl-RS" dirty="0" smtClean="0"/>
+              <a:rPr lang="sr-Cyrl-RS" dirty="0"/>
               <a:t>перформансе</a:t>
             </a:r>
             <a:r>
-              <a:rPr dirty="0" smtClean="0"/>
-              <a:t> </a:t>
-            </a:r>
-            <a:r>
-              <a:rPr dirty="0"/>
-              <a:t>(90.87%).</a:t>
+              <a:rPr dirty="0"/>
+              <a:t> (90.87%).</a:t>
             </a:r>
           </a:p>
         </p:txBody>
@@ -4494,13 +4450,6 @@
   <p:clrMapOvr>
     <a:masterClrMapping/>
   </p:clrMapOvr>
-  <p:timing>
-    <p:tnLst>
-      <p:par>
-        <p:cTn id="1" dur="indefinite" restart="never" nodeType="tmRoot"/>
-      </p:par>
-    </p:tnLst>
-  </p:timing>
 </p:sld>
 </file>
 
@@ -4595,15 +4544,15 @@
               </a:defRPr>
             </a:pPr>
             <a:r>
-              <a:rPr lang="sr-Cyrl-RS" dirty="0" smtClean="0"/>
+              <a:rPr lang="sr-Cyrl-RS" dirty="0"/>
               <a:t>Корелациона анализа </a:t>
             </a:r>
             <a:r>
-              <a:rPr dirty="0" smtClean="0"/>
+              <a:rPr dirty="0"/>
               <a:t>- </a:t>
             </a:r>
             <a:r>
-              <a:rPr lang="sr-Cyrl-RS" dirty="0" smtClean="0"/>
+              <a:rPr lang="sr-Cyrl-RS" dirty="0"/>
               <a:t>методологија</a:t>
             </a:r>
             <a:endParaRPr dirty="0"/>
@@ -4643,9 +4592,10 @@
               </a:defRPr>
             </a:pPr>
             <a:r>
-              <a:rPr dirty="0"/>
-              <a:t>Sentiment Scoring</a:t>
-            </a:r>
+              <a:rPr lang="sr-Cyrl-RS" dirty="0"/>
+              <a:t>Бодовање сентимента</a:t>
+            </a:r>
+            <a:endParaRPr dirty="0"/>
           </a:p>
           <a:p>
             <a:pPr>
@@ -4659,48 +4609,36 @@
               </a:defRPr>
             </a:pPr>
             <a:r>
-              <a:rPr lang="sr-Cyrl-RS" dirty="0" smtClean="0"/>
+              <a:rPr lang="sr-Cyrl-RS" dirty="0"/>
               <a:t>Сваки твит класификован у 3 класе</a:t>
             </a:r>
             <a:r>
-              <a:rPr dirty="0" smtClean="0"/>
+              <a:rPr dirty="0"/>
               <a:t>: </a:t>
             </a:r>
             <a:r>
-              <a:rPr lang="sr-Cyrl-RS" dirty="0" smtClean="0"/>
+              <a:rPr lang="sr-Cyrl-RS" dirty="0"/>
               <a:t>позитиван</a:t>
             </a:r>
             <a:r>
-              <a:rPr dirty="0" smtClean="0"/>
-              <a:t> </a:t>
-            </a:r>
-            <a:r>
-              <a:rPr dirty="0"/>
-              <a:t>(+1), </a:t>
-            </a:r>
-            <a:r>
-              <a:rPr lang="sr-Cyrl-RS" dirty="0" smtClean="0"/>
+              <a:rPr dirty="0"/>
+              <a:t> (+1), </a:t>
+            </a:r>
+            <a:r>
+              <a:rPr lang="sr-Cyrl-RS" dirty="0"/>
               <a:t>неутралан</a:t>
             </a:r>
             <a:r>
-              <a:rPr dirty="0" smtClean="0"/>
-              <a:t> </a:t>
-            </a:r>
-            <a:r>
-              <a:rPr dirty="0"/>
-              <a:t>(0), </a:t>
-            </a:r>
-            <a:r>
-              <a:rPr lang="sr-Cyrl-RS" dirty="0" smtClean="0"/>
+              <a:rPr dirty="0"/>
+              <a:t> (0), </a:t>
+            </a:r>
+            <a:r>
+              <a:rPr lang="sr-Cyrl-RS" dirty="0"/>
               <a:t>негативан</a:t>
             </a:r>
             <a:r>
-              <a:rPr dirty="0" smtClean="0"/>
-              <a:t> </a:t>
-            </a:r>
-            <a:r>
-              <a:rPr dirty="0"/>
-              <a:t>(-1)</a:t>
+              <a:rPr dirty="0"/>
+              <a:t> (-1)</a:t>
             </a:r>
           </a:p>
           <a:p>
@@ -4715,19 +4653,15 @@
               </a:defRPr>
             </a:pPr>
             <a:r>
-              <a:rPr lang="sr-Cyrl-RS" dirty="0" smtClean="0"/>
-              <a:t>Дневни</a:t>
-            </a:r>
-            <a:r>
-              <a:rPr dirty="0" smtClean="0"/>
-              <a:t> </a:t>
-            </a:r>
-            <a:r>
-              <a:rPr dirty="0"/>
-              <a:t>sentiment score = </a:t>
-            </a:r>
-            <a:r>
-              <a:rPr lang="sr-Cyrl-RS" dirty="0" smtClean="0"/>
+              <a:rPr lang="sr-Cyrl-RS" dirty="0"/>
+              <a:t>Дневно бодовање сентимента </a:t>
+            </a:r>
+            <a:r>
+              <a:rPr dirty="0"/>
+              <a:t>= </a:t>
+            </a:r>
+            <a:r>
+              <a:rPr lang="sr-Cyrl-RS" dirty="0"/>
               <a:t>просек свих твитова тог дана</a:t>
             </a:r>
             <a:endParaRPr dirty="0"/>
@@ -4744,54 +4678,37 @@
               </a:defRPr>
             </a:pPr>
             <a:r>
-              <a:rPr lang="sr-Cyrl-RS" dirty="0" smtClean="0"/>
+              <a:rPr lang="sr-Cyrl-RS" dirty="0"/>
               <a:t>Опсег вредности</a:t>
             </a:r>
             <a:r>
-              <a:rPr dirty="0" smtClean="0"/>
-              <a:t>: </a:t>
-            </a:r>
-            <a:r>
-              <a:rPr dirty="0"/>
-              <a:t>-1.0 </a:t>
-            </a:r>
-            <a:r>
-              <a:rPr dirty="0" smtClean="0"/>
-              <a:t>(</a:t>
-            </a:r>
-            <a:r>
-              <a:rPr lang="sr-Cyrl-RS" dirty="0" smtClean="0"/>
+              <a:rPr dirty="0"/>
+              <a:t>: -1.0 (</a:t>
+            </a:r>
+            <a:r>
+              <a:rPr lang="sr-Cyrl-RS" dirty="0"/>
               <a:t>врло негативан</a:t>
             </a:r>
             <a:r>
-              <a:rPr dirty="0" smtClean="0"/>
+              <a:rPr dirty="0"/>
               <a:t>) </a:t>
             </a:r>
             <a:r>
-              <a:rPr lang="sr-Cyrl-RS" dirty="0" smtClean="0"/>
+              <a:rPr lang="sr-Cyrl-RS" dirty="0"/>
               <a:t>до</a:t>
             </a:r>
             <a:r>
-              <a:rPr dirty="0" smtClean="0"/>
-              <a:t> </a:t>
-            </a:r>
-            <a:r>
-              <a:rPr dirty="0"/>
-              <a:t>+1.0 </a:t>
-            </a:r>
-            <a:r>
-              <a:rPr dirty="0" smtClean="0"/>
-              <a:t>(</a:t>
-            </a:r>
-            <a:r>
-              <a:rPr lang="sr-Cyrl-RS" dirty="0" smtClean="0"/>
+              <a:rPr dirty="0"/>
+              <a:t> +1.0 (</a:t>
+            </a:r>
+            <a:r>
+              <a:rPr lang="sr-Cyrl-RS" dirty="0"/>
               <a:t>врло позитиван</a:t>
             </a:r>
             <a:r>
-              <a:rPr dirty="0" smtClean="0"/>
+              <a:rPr dirty="0"/>
               <a:t>)</a:t>
             </a:r>
-            <a:endParaRPr dirty="0"/>
           </a:p>
           <a:p>
             <a:pPr>
@@ -4805,9 +4722,18 @@
               </a:defRPr>
             </a:pPr>
             <a:r>
-              <a:rPr dirty="0"/>
-              <a:t>Bitcoin Price Data</a:t>
-            </a:r>
+              <a:rPr lang="sr-Cyrl-RS" dirty="0"/>
+              <a:t>Подаци о цени </a:t>
+            </a:r>
+            <a:r>
+              <a:rPr lang="en-US" dirty="0"/>
+              <a:t>Bitcoin-</a:t>
+            </a:r>
+            <a:r>
+              <a:rPr lang="sr-Cyrl-RS" dirty="0"/>
+              <a:t>а</a:t>
+            </a:r>
+            <a:endParaRPr dirty="0"/>
           </a:p>
           <a:p>
             <a:pPr>
@@ -4821,20 +4747,16 @@
               </a:defRPr>
             </a:pPr>
             <a:r>
-              <a:rPr lang="sr-Cyrl-RS" dirty="0" smtClean="0"/>
+              <a:rPr lang="sr-Cyrl-RS" dirty="0"/>
               <a:t>Преузето преко </a:t>
             </a:r>
             <a:r>
-              <a:rPr dirty="0" err="1" smtClean="0"/>
+              <a:rPr dirty="0" err="1"/>
               <a:t>yfinance</a:t>
             </a:r>
             <a:r>
-              <a:rPr dirty="0" smtClean="0"/>
-              <a:t> </a:t>
-            </a:r>
-            <a:r>
-              <a:rPr dirty="0"/>
-              <a:t>API</a:t>
+              <a:rPr dirty="0"/>
+              <a:t> API</a:t>
             </a:r>
           </a:p>
           <a:p>
@@ -4849,46 +4771,37 @@
               </a:defRPr>
             </a:pPr>
             <a:r>
-              <a:rPr lang="sr-Cyrl-RS" dirty="0" smtClean="0"/>
+              <a:rPr lang="sr-Cyrl-RS" dirty="0"/>
               <a:t>Временски период</a:t>
             </a:r>
             <a:r>
-              <a:rPr dirty="0" smtClean="0"/>
+              <a:rPr dirty="0"/>
               <a:t>: </a:t>
             </a:r>
             <a:r>
-              <a:rPr lang="sr-Cyrl-RS" dirty="0" smtClean="0"/>
+              <a:rPr lang="sr-Cyrl-RS" dirty="0"/>
               <a:t>Јануар</a:t>
             </a:r>
             <a:r>
-              <a:rPr dirty="0" smtClean="0"/>
-              <a:t> </a:t>
-            </a:r>
-            <a:r>
-              <a:rPr dirty="0"/>
-              <a:t>- </a:t>
-            </a:r>
-            <a:r>
-              <a:rPr lang="sr-Cyrl-RS" dirty="0" smtClean="0"/>
+              <a:rPr dirty="0"/>
+              <a:t> - </a:t>
+            </a:r>
+            <a:r>
+              <a:rPr lang="sr-Cyrl-RS" dirty="0"/>
               <a:t>Мај</a:t>
             </a:r>
             <a:r>
-              <a:rPr dirty="0" smtClean="0"/>
-              <a:t> </a:t>
-            </a:r>
-            <a:r>
-              <a:rPr dirty="0"/>
-              <a:t>2024 (106 </a:t>
-            </a:r>
-            <a:r>
-              <a:rPr lang="sr-Cyrl-RS" dirty="0" smtClean="0"/>
+              <a:rPr dirty="0"/>
+              <a:t> 2024 (106 </a:t>
+            </a:r>
+            <a:r>
+              <a:rPr lang="sr-Cyrl-RS" dirty="0"/>
               <a:t>дана</a:t>
             </a:r>
             <a:r>
-              <a:rPr dirty="0" smtClean="0"/>
+              <a:rPr dirty="0"/>
               <a:t>)</a:t>
             </a:r>
-            <a:endParaRPr dirty="0"/>
           </a:p>
           <a:p>
             <a:pPr>
@@ -4902,16 +4815,12 @@
               </a:defRPr>
             </a:pPr>
             <a:r>
-              <a:rPr lang="sr-Cyrl-RS" dirty="0" smtClean="0"/>
+              <a:rPr lang="sr-Cyrl-RS" dirty="0"/>
               <a:t>Метрике</a:t>
             </a:r>
             <a:r>
-              <a:rPr dirty="0" smtClean="0"/>
-              <a:t>: </a:t>
-            </a:r>
-            <a:r>
-              <a:rPr dirty="0"/>
-              <a:t>closing price, volume, daily change (%)</a:t>
+              <a:rPr dirty="0"/>
+              <a:t>: closing price, volume, daily change (%)</a:t>
             </a:r>
           </a:p>
           <a:p>
@@ -4926,7 +4835,7 @@
               </a:defRPr>
             </a:pPr>
             <a:r>
-              <a:rPr lang="sr-Cyrl-RS" dirty="0" smtClean="0"/>
+              <a:rPr lang="sr-Cyrl-RS" dirty="0"/>
               <a:t>Статистичка анализа</a:t>
             </a:r>
             <a:endParaRPr dirty="0"/>
@@ -4944,18 +4853,22 @@
             </a:pPr>
             <a:r>
               <a:rPr dirty="0"/>
-              <a:t>Pearson correlation </a:t>
-            </a:r>
-            <a:r>
-              <a:rPr lang="en-US" dirty="0" smtClean="0"/>
+              <a:t>Pearson </a:t>
+            </a:r>
+            <a:r>
+              <a:rPr lang="sr-Cyrl-RS" dirty="0"/>
+              <a:t>корелација</a:t>
+            </a:r>
+            <a:r>
+              <a:rPr lang="en-US" dirty="0"/>
               <a:t>–</a:t>
             </a:r>
             <a:r>
-              <a:rPr dirty="0" smtClean="0"/>
+              <a:rPr dirty="0"/>
               <a:t> </a:t>
             </a:r>
             <a:r>
-              <a:rPr lang="sr-Cyrl-RS" dirty="0" smtClean="0"/>
+              <a:rPr lang="sr-Cyrl-RS" dirty="0"/>
               <a:t>линеарна веза</a:t>
             </a:r>
             <a:endParaRPr dirty="0"/>
@@ -4973,18 +4886,26 @@
             </a:pPr>
             <a:r>
               <a:rPr dirty="0"/>
-              <a:t>Spearman correlation </a:t>
-            </a:r>
-            <a:r>
-              <a:rPr lang="en-US" dirty="0" smtClean="0"/>
+              <a:t>Spearman </a:t>
+            </a:r>
+            <a:r>
+              <a:rPr lang="sr-Cyrl-RS" dirty="0"/>
+              <a:t>корелација</a:t>
+            </a:r>
+            <a:r>
+              <a:rPr dirty="0"/>
+              <a:t> </a:t>
+            </a:r>
+            <a:r>
+              <a:rPr lang="en-US" dirty="0"/>
               <a:t>–</a:t>
             </a:r>
             <a:r>
-              <a:rPr dirty="0" smtClean="0"/>
+              <a:rPr dirty="0"/>
               <a:t> </a:t>
             </a:r>
             <a:r>
-              <a:rPr lang="sr-Cyrl-RS" dirty="0" smtClean="0"/>
+              <a:rPr lang="sr-Cyrl-RS" dirty="0"/>
               <a:t>монотона веза</a:t>
             </a:r>
             <a:endParaRPr dirty="0"/>
@@ -5001,50 +4922,49 @@
               </a:defRPr>
             </a:pPr>
             <a:r>
-              <a:rPr dirty="0"/>
-              <a:t>Lag analysis </a:t>
-            </a:r>
-            <a:r>
-              <a:rPr lang="en-US" dirty="0" smtClean="0"/>
+              <a:rPr lang="sr-Cyrl-RS" dirty="0"/>
+              <a:t>Анализа кашњења (енгл. </a:t>
+            </a:r>
+            <a:r>
+              <a:rPr lang="en-US" dirty="0"/>
+              <a:t>lag analysis</a:t>
+            </a:r>
+            <a:r>
+              <a:rPr lang="sr-Cyrl-RS" dirty="0"/>
+              <a:t>)</a:t>
+            </a:r>
+            <a:r>
+              <a:rPr lang="en-US" dirty="0"/>
               <a:t>–</a:t>
             </a:r>
             <a:r>
-              <a:rPr dirty="0" smtClean="0"/>
+              <a:rPr dirty="0"/>
               <a:t> </a:t>
             </a:r>
             <a:r>
-              <a:rPr lang="sr-Cyrl-RS" dirty="0" smtClean="0"/>
+              <a:rPr lang="sr-Cyrl-RS" dirty="0"/>
               <a:t>провера временског кашњења </a:t>
             </a:r>
             <a:r>
-              <a:rPr dirty="0" smtClean="0"/>
-              <a:t>(-</a:t>
-            </a:r>
-            <a:r>
-              <a:rPr dirty="0"/>
-              <a:t>7 </a:t>
-            </a:r>
-            <a:r>
-              <a:rPr lang="sr-Cyrl-RS" dirty="0" smtClean="0"/>
+              <a:rPr dirty="0"/>
+              <a:t>(-7 </a:t>
+            </a:r>
+            <a:r>
+              <a:rPr lang="sr-Cyrl-RS" dirty="0"/>
               <a:t>до</a:t>
             </a:r>
             <a:r>
-              <a:rPr dirty="0" smtClean="0"/>
-              <a:t> </a:t>
-            </a:r>
-            <a:r>
-              <a:rPr dirty="0"/>
-              <a:t>+7 </a:t>
-            </a:r>
-            <a:r>
-              <a:rPr lang="sr-Cyrl-RS" dirty="0" smtClean="0"/>
+              <a:rPr dirty="0"/>
+              <a:t> +7 </a:t>
+            </a:r>
+            <a:r>
+              <a:rPr lang="sr-Cyrl-RS" dirty="0"/>
               <a:t>дана</a:t>
             </a:r>
             <a:r>
-              <a:rPr dirty="0" smtClean="0"/>
+              <a:rPr dirty="0"/>
               <a:t>)</a:t>
             </a:r>
-            <a:endParaRPr dirty="0"/>
           </a:p>
           <a:p>
             <a:pPr>
@@ -5062,7 +4982,7 @@
               <a:t>P-value &lt; 0.05 </a:t>
             </a:r>
             <a:r>
-              <a:rPr lang="sr-Cyrl-RS" dirty="0" smtClean="0"/>
+              <a:rPr lang="sr-Cyrl-RS" dirty="0"/>
               <a:t>за статистичку значајност</a:t>
             </a:r>
             <a:endParaRPr dirty="0"/>
@@ -5074,13 +4994,6 @@
   <p:clrMapOvr>
     <a:masterClrMapping/>
   </p:clrMapOvr>
-  <p:timing>
-    <p:tnLst>
-      <p:par>
-        <p:cTn id="1" dur="indefinite" restart="never" nodeType="tmRoot"/>
-      </p:par>
-    </p:tnLst>
-  </p:timing>
 </p:sld>
 </file>
 
@@ -5175,7 +5088,7 @@
               </a:defRPr>
             </a:pPr>
             <a:r>
-              <a:rPr lang="sr-Cyrl-RS" dirty="0" smtClean="0"/>
+              <a:rPr lang="sr-Cyrl-RS" dirty="0"/>
               <a:t>Корелациона анализа - резултати</a:t>
             </a:r>
             <a:endParaRPr dirty="0"/>
@@ -5237,7 +5150,7 @@
         <p:spPr>
           <a:xfrm>
             <a:off x="1188720" y="1920240"/>
-            <a:ext cx="2737031" cy="338554"/>
+            <a:ext cx="3414589" cy="338554"/>
           </a:xfrm>
           <a:prstGeom prst="rect">
             <a:avLst/>
@@ -5258,22 +5171,21 @@
               </a:defRPr>
             </a:pPr>
             <a:r>
-              <a:rPr dirty="0"/>
-              <a:t>Sentiment vs Price </a:t>
-            </a:r>
-            <a:r>
-              <a:rPr dirty="0" smtClean="0"/>
+              <a:rPr lang="sr-Cyrl-RS" dirty="0"/>
+              <a:t>Сентимент наспрам цене </a:t>
+            </a:r>
+            <a:r>
+              <a:rPr dirty="0"/>
               <a:t>(</a:t>
             </a:r>
             <a:r>
-              <a:rPr lang="sr-Cyrl-RS" dirty="0" smtClean="0"/>
+              <a:rPr lang="sr-Cyrl-RS" dirty="0"/>
               <a:t>тренутно</a:t>
             </a:r>
             <a:r>
-              <a:rPr dirty="0" smtClean="0"/>
+              <a:rPr dirty="0"/>
               <a:t>)</a:t>
             </a:r>
-            <a:endParaRPr dirty="0"/>
           </a:p>
         </p:txBody>
       </p:sp>
@@ -5347,7 +5259,7 @@
               <a:t>❌ </a:t>
             </a:r>
             <a:r>
-              <a:rPr lang="sr-Cyrl-RS" dirty="0" smtClean="0"/>
+              <a:rPr lang="sr-Cyrl-RS" dirty="0"/>
               <a:t>Није статистички значајно</a:t>
             </a:r>
             <a:endParaRPr dirty="0"/>
@@ -5409,7 +5321,7 @@
         <p:spPr>
           <a:xfrm>
             <a:off x="1188720" y="3108960"/>
-            <a:ext cx="1972335" cy="338554"/>
+            <a:ext cx="2626616" cy="338554"/>
           </a:xfrm>
           <a:prstGeom prst="rect">
             <a:avLst/>
@@ -5430,18 +5342,21 @@
               </a:defRPr>
             </a:pPr>
             <a:r>
-              <a:rPr dirty="0"/>
-              <a:t>Lag Analysis (6 </a:t>
-            </a:r>
-            <a:r>
-              <a:rPr lang="sr-Cyrl-RS" dirty="0" smtClean="0"/>
+              <a:rPr lang="sr-Cyrl-RS" dirty="0"/>
+              <a:t>Анализа кашњења </a:t>
+            </a:r>
+            <a:r>
+              <a:rPr dirty="0"/>
+              <a:t>(6 </a:t>
+            </a:r>
+            <a:r>
+              <a:rPr lang="sr-Cyrl-RS" dirty="0"/>
               <a:t>дана</a:t>
             </a:r>
             <a:r>
-              <a:rPr dirty="0" smtClean="0"/>
+              <a:rPr dirty="0"/>
               <a:t>)</a:t>
             </a:r>
-            <a:endParaRPr dirty="0"/>
           </a:p>
         </p:txBody>
       </p:sp>
@@ -5514,7 +5429,7 @@
               <a:t>✅ </a:t>
             </a:r>
             <a:r>
-              <a:rPr lang="sr-Cyrl-RS" dirty="0" smtClean="0"/>
+              <a:rPr lang="sr-Cyrl-RS" dirty="0"/>
               <a:t>Статистички значајно!</a:t>
             </a:r>
             <a:endParaRPr dirty="0"/>
@@ -5597,7 +5512,7 @@
               </a:defRPr>
             </a:pPr>
             <a:r>
-              <a:rPr lang="sr-Cyrl-RS" dirty="0" smtClean="0"/>
+              <a:rPr lang="sr-Cyrl-RS" dirty="0"/>
               <a:t>Интерпретација</a:t>
             </a:r>
             <a:endParaRPr dirty="0"/>
@@ -5634,7 +5549,7 @@
               </a:defRPr>
             </a:pPr>
             <a:r>
-              <a:rPr lang="sr-Cyrl-RS" dirty="0" smtClean="0"/>
+              <a:rPr lang="sr-Cyrl-RS" dirty="0"/>
               <a:t>Цена води сентимент</a:t>
             </a:r>
             <a:endParaRPr dirty="0"/>
@@ -5671,7 +5586,7 @@
               </a:defRPr>
             </a:pPr>
             <a:r>
-              <a:rPr lang="sr-Cyrl-RS" dirty="0" smtClean="0"/>
+              <a:rPr lang="sr-Cyrl-RS" dirty="0"/>
               <a:t>Сентимент реагује на цену</a:t>
             </a:r>
             <a:endParaRPr dirty="0"/>
@@ -5755,36 +5670,24 @@
               </a:defRPr>
             </a:pPr>
             <a:r>
-              <a:rPr lang="ru-RU" dirty="0" smtClean="0"/>
-              <a:t>Кључни </a:t>
-            </a:r>
-            <a:r>
               <a:rPr lang="ru-RU" dirty="0"/>
-              <a:t>налаз: </a:t>
-            </a:r>
-            <a:r>
-              <a:rPr lang="en-US" dirty="0" smtClean="0"/>
+              <a:t>Кључни налаз: </a:t>
+            </a:r>
+            <a:r>
+              <a:rPr lang="en-US" dirty="0"/>
               <a:t>Twitter</a:t>
             </a:r>
             <a:r>
-              <a:rPr lang="ru-RU" dirty="0" smtClean="0"/>
-              <a:t> </a:t>
-            </a:r>
-            <a:r>
               <a:rPr lang="ru-RU" dirty="0"/>
-              <a:t>сентимент НЕ предвиђа </a:t>
-            </a:r>
-            <a:r>
-              <a:rPr lang="en-US" dirty="0" smtClean="0"/>
+              <a:t> сентимент НЕ предвиђа </a:t>
+            </a:r>
+            <a:r>
+              <a:rPr lang="en-US" dirty="0"/>
               <a:t>Bitcoin</a:t>
             </a:r>
             <a:r>
-              <a:rPr lang="ru-RU" dirty="0" smtClean="0"/>
-              <a:t> </a:t>
-            </a:r>
-            <a:r>
               <a:rPr lang="ru-RU" dirty="0"/>
-              <a:t>цену, већ реагује на њу са кашњењем од ~6 дана. Корисници коментаришу постојеће кретање цене уместо да антиципирају будуће промене.</a:t>
+              <a:t> цену, већ реагује на њу са кашњењем од ~6 дана. Корисници коментаришу постојеће кретање цене уместо да антиципирају будуће промене.</a:t>
             </a:r>
             <a:endParaRPr dirty="0"/>
           </a:p>
@@ -5795,13 +5698,6 @@
   <p:clrMapOvr>
     <a:masterClrMapping/>
   </p:clrMapOvr>
-  <p:timing>
-    <p:tnLst>
-      <p:par>
-        <p:cTn id="1" dur="indefinite" restart="never" nodeType="tmRoot"/>
-      </p:par>
-    </p:tnLst>
-  </p:timing>
 </p:sld>
 </file>
 
@@ -5896,7 +5792,7 @@
               </a:defRPr>
             </a:pPr>
             <a:r>
-              <a:rPr lang="sr-Cyrl-RS" dirty="0" smtClean="0"/>
+              <a:rPr lang="sr-Cyrl-RS" dirty="0"/>
               <a:t>Евалуација и метрике</a:t>
             </a:r>
             <a:endParaRPr dirty="0"/>
@@ -5936,9 +5832,10 @@
               </a:defRPr>
             </a:pPr>
             <a:r>
-              <a:rPr dirty="0"/>
-              <a:t>Classification Metrics</a:t>
-            </a:r>
+              <a:rPr lang="sr-Cyrl-RS" dirty="0"/>
+              <a:t>Метрике класификације</a:t>
+            </a:r>
+            <a:endParaRPr dirty="0"/>
           </a:p>
           <a:p>
             <a:pPr>
@@ -5952,11 +5849,15 @@
               </a:defRPr>
             </a:pPr>
             <a:r>
-              <a:rPr dirty="0"/>
-              <a:t>Accuracy: </a:t>
-            </a:r>
-            <a:r>
-              <a:rPr lang="sr-Cyrl-RS" dirty="0" smtClean="0"/>
+              <a:rPr lang="en-US" dirty="0"/>
+              <a:t>Accuracy</a:t>
+            </a:r>
+            <a:r>
+              <a:rPr dirty="0"/>
+              <a:t>: </a:t>
+            </a:r>
+            <a:r>
+              <a:rPr lang="sr-Cyrl-RS" dirty="0"/>
               <a:t>Укупна тачност класификације</a:t>
             </a:r>
             <a:endParaRPr dirty="0"/>
@@ -5977,7 +5878,7 @@
               <a:t>Precision: </a:t>
             </a:r>
             <a:r>
-              <a:rPr lang="sr-Cyrl-RS" dirty="0" smtClean="0"/>
+              <a:rPr lang="sr-Cyrl-RS" dirty="0"/>
               <a:t>Тачност позитивних предикција</a:t>
             </a:r>
             <a:endParaRPr dirty="0"/>
@@ -5999,11 +5900,7 @@
             </a:r>
             <a:r>
               <a:rPr lang="sr-Cyrl-RS" dirty="0"/>
-              <a:t>Покривеност стварних позитивних </a:t>
-            </a:r>
-            <a:r>
-              <a:rPr lang="sr-Cyrl-RS" dirty="0" smtClean="0"/>
-              <a:t>случајева</a:t>
+              <a:t>Покривеност стварних позитивних случајева</a:t>
             </a:r>
           </a:p>
           <a:p>
@@ -6018,25 +5915,38 @@
               </a:defRPr>
             </a:pPr>
             <a:r>
-              <a:rPr dirty="0" smtClean="0"/>
+              <a:rPr dirty="0"/>
               <a:t>F1-Score: </a:t>
             </a:r>
             <a:r>
-              <a:rPr lang="sr-Cyrl-RS" dirty="0" smtClean="0"/>
+              <a:rPr lang="sr-Cyrl-RS" dirty="0"/>
               <a:t>Хармонијска средина </a:t>
             </a:r>
             <a:r>
-              <a:rPr dirty="0" smtClean="0"/>
-              <a:t>precision </a:t>
-            </a:r>
-            <a:r>
-              <a:rPr lang="sr-Cyrl-RS" dirty="0" err="1"/>
+              <a:rPr dirty="0"/>
+              <a:t>precision</a:t>
+            </a:r>
+            <a:r>
+              <a:rPr lang="sr-Cyrl-RS" dirty="0"/>
+              <a:t>-а</a:t>
+            </a:r>
+            <a:r>
+              <a:rPr dirty="0"/>
+              <a:t> </a:t>
+            </a:r>
+            <a:r>
+              <a:rPr lang="sr-Cyrl-RS" dirty="0"/>
               <a:t>и</a:t>
             </a:r>
             <a:r>
-              <a:rPr dirty="0" smtClean="0"/>
+              <a:rPr dirty="0"/>
               <a:t> recall</a:t>
             </a:r>
+            <a:r>
+              <a:rPr lang="sr-Cyrl-RS" dirty="0"/>
+              <a:t>-а</a:t>
+            </a:r>
+            <a:endParaRPr dirty="0"/>
           </a:p>
           <a:p>
             <a:pPr>
@@ -6050,8 +5960,8 @@
               </a:defRPr>
             </a:pPr>
             <a:r>
-              <a:rPr dirty="0" smtClean="0"/>
-              <a:t>Cross-Validation</a:t>
+              <a:rPr lang="sr-Cyrl-RS" dirty="0"/>
+              <a:t>Унакрсна валидација</a:t>
             </a:r>
             <a:endParaRPr dirty="0"/>
           </a:p>
@@ -6068,7 +5978,15 @@
             </a:pPr>
             <a:r>
               <a:rPr dirty="0"/>
-              <a:t>5-Fold stratified cross-validation</a:t>
+              <a:t>5-</a:t>
+            </a:r>
+            <a:r>
+              <a:rPr lang="en-US" dirty="0"/>
+              <a:t>f</a:t>
+            </a:r>
+            <a:r>
+              <a:rPr dirty="0"/>
+              <a:t>old stratified cross-validation</a:t>
             </a:r>
           </a:p>
           <a:p>
@@ -6115,13 +6033,18 @@
               </a:defRPr>
             </a:pPr>
             <a:r>
-              <a:rPr dirty="0" smtClean="0"/>
-              <a:t>Confusion </a:t>
-            </a:r>
-            <a:r>
-              <a:rPr dirty="0"/>
-              <a:t>Matrix</a:t>
-            </a:r>
+              <a:rPr lang="sr-Cyrl-RS" dirty="0"/>
+              <a:t>Матрица конфузије (енгл. </a:t>
+            </a:r>
+            <a:r>
+              <a:rPr dirty="0"/>
+              <a:t>Confusion Matrix</a:t>
+            </a:r>
+            <a:r>
+              <a:rPr lang="sr-Cyrl-RS" dirty="0"/>
+              <a:t>)</a:t>
+            </a:r>
+            <a:endParaRPr dirty="0"/>
           </a:p>
           <a:p>
             <a:pPr>
@@ -6167,12 +6090,8 @@
               </a:defRPr>
             </a:pPr>
             <a:r>
-              <a:rPr dirty="0" smtClean="0"/>
-              <a:t>BERT</a:t>
-            </a:r>
-            <a:r>
-              <a:rPr dirty="0"/>
-              <a:t>: </a:t>
+              <a:rPr dirty="0"/>
+              <a:t>BERT: </a:t>
             </a:r>
             <a:r>
               <a:rPr lang="sr-Cyrl-RS" dirty="0"/>
@@ -6186,13 +6105,6 @@
   <p:clrMapOvr>
     <a:masterClrMapping/>
   </p:clrMapOvr>
-  <p:timing>
-    <p:tnLst>
-      <p:par>
-        <p:cTn id="1" dur="indefinite" restart="never" nodeType="tmRoot"/>
-      </p:par>
-    </p:tnLst>
-  </p:timing>
 </p:sld>
 </file>
 
@@ -6287,7 +6199,7 @@
               </a:defRPr>
             </a:pPr>
             <a:r>
-              <a:rPr lang="sr-Cyrl-RS" dirty="0" smtClean="0"/>
+              <a:rPr lang="sr-Cyrl-RS" dirty="0"/>
               <a:t>Технички изазови и решења</a:t>
             </a:r>
             <a:endParaRPr dirty="0"/>
@@ -6303,7 +6215,7 @@
         <p:spPr>
           <a:xfrm>
             <a:off x="731520" y="1645920"/>
-            <a:ext cx="7772400" cy="3534301"/>
+            <a:ext cx="7772400" cy="4026743"/>
           </a:xfrm>
           <a:prstGeom prst="rect">
             <a:avLst/>
@@ -6327,7 +6239,7 @@
               </a:defRPr>
             </a:pPr>
             <a:r>
-              <a:rPr lang="sr-Cyrl-RS" dirty="0" smtClean="0"/>
+              <a:rPr lang="sr-Cyrl-RS" dirty="0"/>
               <a:t>Изазови</a:t>
             </a:r>
             <a:endParaRPr dirty="0"/>
@@ -6344,29 +6256,62 @@
               </a:defRPr>
             </a:pPr>
             <a:r>
-              <a:rPr lang="sr-Cyrl-RS" dirty="0" smtClean="0"/>
+              <a:rPr lang="sr-Cyrl-RS" dirty="0"/>
               <a:t>Небалансиран</a:t>
             </a:r>
             <a:r>
-              <a:rPr dirty="0" smtClean="0"/>
+              <a:rPr dirty="0"/>
               <a:t> </a:t>
             </a:r>
             <a:r>
-              <a:rPr dirty="0"/>
-              <a:t>dataset → Data augmentation </a:t>
-            </a:r>
-            <a:r>
-              <a:rPr lang="sr-Cyrl-RS" dirty="0" err="1" smtClean="0"/>
+              <a:rPr lang="sr-Cyrl-RS" dirty="0"/>
+              <a:t>скуп података</a:t>
+            </a:r>
+            <a:r>
+              <a:rPr dirty="0"/>
+              <a:t> → </a:t>
+            </a:r>
+            <a:r>
+              <a:rPr lang="sr-Cyrl-RS" dirty="0"/>
+              <a:t>Аугментација података (енгл. </a:t>
+            </a:r>
+            <a:r>
+              <a:rPr lang="en-US" dirty="0"/>
+              <a:t>d</a:t>
+            </a:r>
+            <a:r>
+              <a:rPr dirty="0"/>
+              <a:t>ata augmentation</a:t>
+            </a:r>
+            <a:r>
+              <a:rPr lang="sr-Cyrl-RS" dirty="0"/>
+              <a:t>)</a:t>
+            </a:r>
+            <a:r>
+              <a:rPr dirty="0"/>
+              <a:t> </a:t>
+            </a:r>
+            <a:r>
+              <a:rPr lang="sr-Cyrl-RS" dirty="0"/>
               <a:t>и</a:t>
             </a:r>
             <a:r>
-              <a:rPr dirty="0" smtClean="0"/>
+              <a:rPr dirty="0"/>
               <a:t> </a:t>
             </a:r>
             <a:r>
+              <a:rPr lang="sr-Cyrl-RS" dirty="0"/>
+              <a:t>пондерисани губитак (енгл. </a:t>
+            </a:r>
+            <a:r>
               <a:rPr dirty="0"/>
               <a:t>weighted loss</a:t>
             </a:r>
+            <a:r>
+              <a:rPr lang="sr-Cyrl-RS" dirty="0"/>
+              <a:t>)</a:t>
+            </a:r>
+            <a:endParaRPr dirty="0"/>
           </a:p>
           <a:p>
             <a:pPr>
@@ -6380,25 +6325,18 @@
               </a:defRPr>
             </a:pPr>
             <a:r>
-              <a:rPr lang="sr-Cyrl-RS" dirty="0" smtClean="0"/>
+              <a:rPr lang="sr-Cyrl-RS" dirty="0"/>
               <a:t>Сленг и нестандардан језик </a:t>
             </a:r>
             <a:r>
-              <a:rPr dirty="0" smtClean="0"/>
+              <a:rPr dirty="0"/>
               <a:t>→ </a:t>
             </a:r>
             <a:r>
-              <a:rPr lang="sr-Cyrl-RS" dirty="0" smtClean="0"/>
-              <a:t>Екстензивни</a:t>
-            </a:r>
-            <a:r>
-              <a:rPr dirty="0" smtClean="0"/>
-              <a:t> </a:t>
-            </a:r>
-            <a:r>
-              <a:rPr dirty="0"/>
-              <a:t>preprocessing</a:t>
-            </a:r>
+              <a:rPr lang="sr-Cyrl-RS" dirty="0"/>
+              <a:t>Екстензивно претпроцесирање</a:t>
+            </a:r>
+            <a:endParaRPr dirty="0"/>
           </a:p>
           <a:p>
             <a:pPr>
@@ -6413,19 +6351,23 @@
             </a:pPr>
             <a:r>
               <a:rPr dirty="0"/>
-              <a:t>BERT GPU memory → Batch size </a:t>
-            </a:r>
-            <a:r>
-              <a:rPr lang="sr-Cyrl-RS" dirty="0" smtClean="0"/>
+              <a:t>BERT GPU </a:t>
+            </a:r>
+            <a:r>
+              <a:rPr lang="sr-Cyrl-RS" dirty="0"/>
+              <a:t>меморија</a:t>
+            </a:r>
+            <a:r>
+              <a:rPr dirty="0"/>
+              <a:t> → Batch size </a:t>
+            </a:r>
+            <a:r>
+              <a:rPr lang="sr-Cyrl-RS" dirty="0"/>
               <a:t>оптимизација</a:t>
             </a:r>
             <a:r>
-              <a:rPr dirty="0" smtClean="0"/>
-              <a:t> </a:t>
-            </a:r>
-            <a:r>
-              <a:rPr dirty="0"/>
-              <a:t>(16)</a:t>
+              <a:rPr dirty="0"/>
+              <a:t> (16)</a:t>
             </a:r>
           </a:p>
           <a:p>
@@ -6440,21 +6382,66 @@
               </a:defRPr>
             </a:pPr>
             <a:r>
-              <a:rPr dirty="0"/>
-              <a:t>Overfitting → Dropout (0.3) </a:t>
-            </a:r>
-            <a:r>
-              <a:rPr lang="sr-Cyrl-RS" dirty="0" err="1" smtClean="0"/>
+              <a:rPr lang="sr-Cyrl-RS" sz="1600" dirty="0"/>
+              <a:t>Преобучавање (енгл. </a:t>
+            </a:r>
+            <a:r>
+              <a:rPr lang="en-US" sz="1600" dirty="0"/>
+              <a:t>o</a:t>
+            </a:r>
+            <a:r>
+              <a:rPr dirty="0"/>
+              <a:t>verfitting</a:t>
+            </a:r>
+            <a:r>
+              <a:rPr lang="sr-Cyrl-RS" dirty="0"/>
+              <a:t>)</a:t>
+            </a:r>
+            <a:r>
+              <a:rPr dirty="0"/>
+              <a:t> → </a:t>
+            </a:r>
+            <a:r>
+              <a:rPr lang="sr-Cyrl-RS" dirty="0"/>
+              <a:t>Испадање (енгл. </a:t>
+            </a:r>
+            <a:r>
+              <a:rPr lang="en-US" dirty="0"/>
+              <a:t>d</a:t>
+            </a:r>
+            <a:r>
+              <a:rPr dirty="0"/>
+              <a:t>ropout</a:t>
+            </a:r>
+            <a:r>
+              <a:rPr lang="sr-Cyrl-RS" dirty="0"/>
+              <a:t>)</a:t>
+            </a:r>
+            <a:r>
+              <a:rPr dirty="0"/>
+              <a:t> (0.3) </a:t>
+            </a:r>
+            <a:r>
+              <a:rPr lang="sr-Cyrl-RS" dirty="0"/>
               <a:t>и</a:t>
             </a:r>
             <a:r>
-              <a:rPr dirty="0" smtClean="0"/>
+              <a:rPr dirty="0"/>
               <a:t> </a:t>
             </a:r>
             <a:r>
+              <a:rPr lang="sr-Cyrl-RS" dirty="0"/>
+              <a:t>превремено заустављање (енгл. </a:t>
+            </a:r>
+            <a:r>
               <a:rPr dirty="0"/>
               <a:t>early stopping</a:t>
             </a:r>
+            <a:r>
+              <a:rPr lang="sr-Cyrl-RS" dirty="0"/>
+              <a:t>)</a:t>
+            </a:r>
+            <a:endParaRPr dirty="0"/>
           </a:p>
           <a:p>
             <a:pPr>
@@ -6468,7 +6455,7 @@
               </a:defRPr>
             </a:pPr>
             <a:r>
-              <a:rPr lang="sr-Cyrl-RS" dirty="0" smtClean="0"/>
+              <a:rPr lang="sr-Cyrl-RS" dirty="0"/>
               <a:t>Оптимизације</a:t>
             </a:r>
             <a:endParaRPr dirty="0"/>
@@ -6486,22 +6473,26 @@
             </a:pPr>
             <a:r>
               <a:rPr dirty="0"/>
-              <a:t>GPU acceleration (RTX 4060) → 10x </a:t>
-            </a:r>
-            <a:r>
-              <a:rPr lang="sr-Cyrl-RS" dirty="0" smtClean="0"/>
+              <a:t>GPU </a:t>
+            </a:r>
+            <a:r>
+              <a:rPr lang="sr-Cyrl-RS" dirty="0"/>
+              <a:t>убрзање</a:t>
+            </a:r>
+            <a:r>
+              <a:rPr dirty="0"/>
+              <a:t> (RTX 4060) → 10x </a:t>
+            </a:r>
+            <a:r>
+              <a:rPr lang="sr-Cyrl-RS" dirty="0"/>
               <a:t>брже</a:t>
             </a:r>
             <a:r>
-              <a:rPr dirty="0" smtClean="0"/>
-              <a:t> </a:t>
-            </a:r>
-            <a:r>
-              <a:rPr dirty="0"/>
-              <a:t>BERT </a:t>
-            </a:r>
-            <a:r>
-              <a:rPr lang="sr-Cyrl-RS" dirty="0" smtClean="0"/>
+              <a:rPr dirty="0"/>
+              <a:t> BERT </a:t>
+            </a:r>
+            <a:r>
+              <a:rPr lang="sr-Cyrl-RS" dirty="0"/>
               <a:t>тренирање</a:t>
             </a:r>
             <a:endParaRPr dirty="0"/>
@@ -6518,12 +6509,12 @@
               </a:defRPr>
             </a:pPr>
             <a:r>
-              <a:rPr dirty="0" err="1"/>
-              <a:t>Hyperparameter</a:t>
-            </a:r>
-            <a:r>
-              <a:rPr dirty="0"/>
-              <a:t> tuning → </a:t>
+              <a:rPr lang="sr-Cyrl-RS" dirty="0"/>
+              <a:t>Подешавање хиперпараметара </a:t>
+            </a:r>
+            <a:r>
+              <a:rPr dirty="0"/>
+              <a:t>→ </a:t>
             </a:r>
             <a:r>
               <a:rPr dirty="0" err="1"/>
@@ -6534,16 +6525,12 @@
               <a:t> </a:t>
             </a:r>
             <a:r>
-              <a:rPr lang="sr-Cyrl-RS" dirty="0" smtClean="0"/>
+              <a:rPr lang="sr-Cyrl-RS" dirty="0"/>
               <a:t>за</a:t>
             </a:r>
             <a:r>
-              <a:rPr dirty="0" smtClean="0"/>
-              <a:t> </a:t>
-            </a:r>
-            <a:r>
-              <a:rPr dirty="0"/>
-              <a:t>SVM</a:t>
+              <a:rPr dirty="0"/>
+              <a:t> SVM</a:t>
             </a:r>
           </a:p>
           <a:p>
@@ -6558,8 +6545,12 @@
               </a:defRPr>
             </a:pPr>
             <a:r>
-              <a:rPr dirty="0"/>
-              <a:t>Learning rate scheduling → </a:t>
+              <a:rPr lang="sr-Cyrl-RS" dirty="0"/>
+              <a:t>Распоред брзине учења </a:t>
+            </a:r>
+            <a:r>
+              <a:rPr dirty="0"/>
+              <a:t>→ </a:t>
             </a:r>
             <a:r>
               <a:rPr dirty="0" err="1"/>
@@ -6570,16 +6561,12 @@
               <a:t> </a:t>
             </a:r>
             <a:r>
-              <a:rPr lang="sr-Cyrl-RS" dirty="0" smtClean="0"/>
+              <a:rPr lang="sr-Cyrl-RS" dirty="0"/>
               <a:t>за</a:t>
             </a:r>
             <a:r>
-              <a:rPr dirty="0" smtClean="0"/>
-              <a:t> </a:t>
-            </a:r>
-            <a:r>
-              <a:rPr dirty="0"/>
-              <a:t>BERT</a:t>
+              <a:rPr dirty="0"/>
+              <a:t> BERT</a:t>
             </a:r>
           </a:p>
           <a:p>
@@ -6594,20 +6581,24 @@
               </a:defRPr>
             </a:pPr>
             <a:r>
-              <a:rPr dirty="0"/>
-              <a:t>Data caching → </a:t>
-            </a:r>
-            <a:r>
-              <a:rPr lang="sr-Cyrl-RS" dirty="0" smtClean="0"/>
+              <a:rPr lang="sr-Cyrl-RS" dirty="0"/>
+              <a:t>Кеширање података</a:t>
+            </a:r>
+            <a:r>
+              <a:rPr dirty="0"/>
+              <a:t> → </a:t>
+            </a:r>
+            <a:r>
+              <a:rPr lang="sr-Cyrl-RS" dirty="0"/>
               <a:t>Убрзање</a:t>
             </a:r>
             <a:r>
-              <a:rPr dirty="0" smtClean="0"/>
-              <a:t> preprocessing-</a:t>
-            </a:r>
-            <a:r>
-              <a:rPr lang="sr-Cyrl-RS" dirty="0" smtClean="0"/>
-              <a:t>а</a:t>
+              <a:rPr dirty="0"/>
+              <a:t> </a:t>
+            </a:r>
+            <a:r>
+              <a:rPr lang="sr-Cyrl-RS" dirty="0"/>
+              <a:t>претпроцесирања</a:t>
             </a:r>
             <a:endParaRPr dirty="0"/>
           </a:p>
@@ -6618,13 +6609,6 @@
   <p:clrMapOvr>
     <a:masterClrMapping/>
   </p:clrMapOvr>
-  <p:timing>
-    <p:tnLst>
-      <p:par>
-        <p:cTn id="1" dur="indefinite" restart="never" nodeType="tmRoot"/>
-      </p:par>
-    </p:tnLst>
-  </p:timing>
 </p:sld>
 </file>
 
@@ -6719,7 +6703,7 @@
               </a:defRPr>
             </a:pPr>
             <a:r>
-              <a:rPr lang="sr-Cyrl-RS" dirty="0" smtClean="0"/>
+              <a:rPr lang="sr-Cyrl-RS" dirty="0"/>
               <a:t>Закључак и будући правци</a:t>
             </a:r>
             <a:endParaRPr dirty="0"/>
@@ -6802,7 +6786,7 @@
               </a:defRPr>
             </a:pPr>
             <a:r>
-              <a:rPr lang="sr-Cyrl-RS" dirty="0" smtClean="0"/>
+              <a:rPr lang="sr-Cyrl-RS" dirty="0"/>
               <a:t>Постигнути резултати</a:t>
             </a:r>
             <a:endParaRPr dirty="0"/>
@@ -6842,38 +6826,26 @@
               </a:defRPr>
             </a:pPr>
             <a:r>
-              <a:rPr dirty="0" smtClean="0"/>
+              <a:rPr dirty="0"/>
               <a:t> </a:t>
             </a:r>
             <a:r>
-              <a:rPr lang="sr-Cyrl-RS" dirty="0" smtClean="0"/>
+              <a:rPr lang="sr-Cyrl-RS" dirty="0"/>
               <a:t>Успешно имплементирана </a:t>
             </a:r>
             <a:r>
-              <a:rPr dirty="0" smtClean="0"/>
-              <a:t>3 </a:t>
-            </a:r>
-            <a:r>
-              <a:rPr dirty="0"/>
-              <a:t>ML </a:t>
-            </a:r>
-            <a:r>
-              <a:rPr lang="sr-Cyrl-RS" dirty="0" smtClean="0"/>
+              <a:rPr dirty="0"/>
+              <a:t>3 ML </a:t>
+            </a:r>
+            <a:r>
+              <a:rPr lang="sr-Cyrl-RS" dirty="0"/>
               <a:t>модела</a:t>
             </a:r>
             <a:r>
-              <a:rPr dirty="0" smtClean="0"/>
-              <a:t> </a:t>
-            </a:r>
-            <a:r>
-              <a:rPr dirty="0"/>
-              <a:t>(Naive Bayes, SVM, BERT</a:t>
-            </a:r>
-            <a:r>
-              <a:rPr dirty="0" smtClean="0"/>
-              <a:t>)</a:t>
-            </a:r>
-            <a:endParaRPr lang="sr-Cyrl-RS" dirty="0" smtClean="0"/>
+              <a:rPr dirty="0"/>
+              <a:t> (Naive Bayes, SVM, BERT)</a:t>
+            </a:r>
+            <a:endParaRPr lang="sr-Cyrl-RS" dirty="0"/>
           </a:p>
           <a:p>
             <a:pPr>
@@ -6887,38 +6859,25 @@
               </a:defRPr>
             </a:pPr>
             <a:r>
-              <a:rPr dirty="0" smtClean="0"/>
+              <a:rPr dirty="0"/>
+              <a:t> SVM </a:t>
+            </a:r>
+            <a:r>
+              <a:rPr lang="sr-Cyrl-RS" dirty="0"/>
+              <a:t>постигао</a:t>
+            </a:r>
+            <a:r>
+              <a:rPr dirty="0"/>
               <a:t> </a:t>
             </a:r>
             <a:r>
-              <a:rPr dirty="0"/>
-              <a:t>SVM </a:t>
-            </a:r>
-            <a:r>
-              <a:rPr lang="sr-Cyrl-RS" dirty="0" smtClean="0"/>
-              <a:t>постигао</a:t>
-            </a:r>
-            <a:r>
-              <a:rPr dirty="0" smtClean="0"/>
-              <a:t> </a:t>
-            </a:r>
-            <a:r>
-              <a:rPr lang="sr-Cyrl-RS" dirty="0" smtClean="0"/>
+              <a:rPr lang="sr-Cyrl-RS" dirty="0"/>
               <a:t>изванредну тачност од</a:t>
             </a:r>
             <a:r>
-              <a:rPr dirty="0" smtClean="0"/>
-              <a:t> </a:t>
-            </a:r>
-            <a:r>
-              <a:rPr dirty="0"/>
-              <a:t>95.24</a:t>
-            </a:r>
-            <a:r>
-              <a:rPr dirty="0" smtClean="0"/>
-              <a:t>%</a:t>
-            </a:r>
-            <a:endParaRPr dirty="0"/>
+              <a:rPr dirty="0"/>
+              <a:t> 95.24%</a:t>
+            </a:r>
           </a:p>
           <a:p>
             <a:pPr>
@@ -6932,36 +6891,32 @@
               </a:defRPr>
             </a:pPr>
             <a:r>
-              <a:rPr dirty="0" smtClean="0"/>
+              <a:rPr dirty="0"/>
+              <a:t> BERT </a:t>
+            </a:r>
+            <a:r>
+              <a:rPr lang="sr-Cyrl-RS" dirty="0"/>
+              <a:t>демонстрирао</a:t>
+            </a:r>
+            <a:r>
+              <a:rPr dirty="0"/>
               <a:t> </a:t>
             </a:r>
             <a:r>
-              <a:rPr dirty="0"/>
-              <a:t>BERT </a:t>
-            </a:r>
-            <a:r>
-              <a:rPr lang="sr-Cyrl-RS" dirty="0" smtClean="0"/>
-              <a:t>демонстрирао</a:t>
-            </a:r>
-            <a:r>
-              <a:rPr dirty="0" smtClean="0"/>
+              <a:rPr lang="sr-Cyrl-RS" dirty="0"/>
+              <a:t>изванредне</a:t>
+            </a:r>
+            <a:r>
+              <a:rPr dirty="0"/>
               <a:t> </a:t>
             </a:r>
             <a:r>
-              <a:rPr dirty="0"/>
-              <a:t>state-of-the-art </a:t>
-            </a:r>
-            <a:r>
-              <a:rPr lang="sr-Cyrl-RS" dirty="0" smtClean="0"/>
+              <a:rPr lang="sr-Cyrl-RS" dirty="0"/>
               <a:t>перформансе</a:t>
             </a:r>
             <a:r>
-              <a:rPr dirty="0" smtClean="0"/>
-              <a:t> </a:t>
-            </a:r>
-            <a:r>
-              <a:rPr dirty="0"/>
-              <a:t>(94.84%)</a:t>
+              <a:rPr dirty="0"/>
+              <a:t> (94.84%)</a:t>
             </a:r>
           </a:p>
           <a:p>
@@ -6976,7 +6931,7 @@
               </a:defRPr>
             </a:pPr>
             <a:r>
-              <a:rPr dirty="0" smtClean="0"/>
+              <a:rPr dirty="0"/>
               <a:t> </a:t>
             </a:r>
             <a:r>
@@ -6984,22 +6939,25 @@
               <a:t>Корелациона анализа открила статистички значајну везу </a:t>
             </a:r>
             <a:r>
-              <a:rPr dirty="0" smtClean="0"/>
+              <a:rPr dirty="0"/>
               <a:t>(</a:t>
             </a:r>
             <a:r>
-              <a:rPr dirty="0"/>
-              <a:t>lag 6 </a:t>
-            </a:r>
-            <a:r>
-              <a:rPr lang="sr-Cyrl-RS" dirty="0" smtClean="0"/>
+              <a:rPr lang="sr-Cyrl-RS" dirty="0"/>
+              <a:t>кашњење</a:t>
+            </a:r>
+            <a:r>
+              <a:rPr dirty="0"/>
+              <a:t> 6 </a:t>
+            </a:r>
+            <a:r>
+              <a:rPr lang="sr-Cyrl-RS" dirty="0"/>
               <a:t>дана</a:t>
             </a:r>
             <a:r>
-              <a:rPr dirty="0" smtClean="0"/>
+              <a:rPr dirty="0"/>
               <a:t>)</a:t>
             </a:r>
-            <a:endParaRPr dirty="0"/>
           </a:p>
           <a:p>
             <a:pPr>
@@ -7013,7 +6971,7 @@
               </a:defRPr>
             </a:pPr>
             <a:r>
-              <a:rPr dirty="0" smtClean="0"/>
+              <a:rPr dirty="0"/>
               <a:t> </a:t>
             </a:r>
             <a:r>
@@ -7097,7 +7055,7 @@
               </a:defRPr>
             </a:pPr>
             <a:r>
-              <a:rPr lang="sr-Cyrl-RS" dirty="0" smtClean="0"/>
+              <a:rPr lang="sr-Cyrl-RS" dirty="0"/>
               <a:t>Будући правци развоја</a:t>
             </a:r>
             <a:endParaRPr dirty="0"/>
@@ -7137,13 +7095,14 @@
               </a:defRPr>
             </a:pPr>
             <a:r>
-              <a:rPr dirty="0" smtClean="0"/>
+              <a:rPr dirty="0"/>
               <a:t> </a:t>
             </a:r>
             <a:r>
-              <a:rPr dirty="0"/>
-              <a:t>Real-time sentiment tracking dashboard</a:t>
-            </a:r>
+              <a:rPr lang="ru-RU" dirty="0"/>
+              <a:t>Контролна табла за праћење сентимента у реалном времену</a:t>
+            </a:r>
+            <a:endParaRPr dirty="0"/>
           </a:p>
           <a:p>
             <a:pPr>
@@ -7157,7 +7116,7 @@
               </a:defRPr>
             </a:pPr>
             <a:r>
-              <a:rPr dirty="0" smtClean="0"/>
+              <a:rPr dirty="0"/>
               <a:t> </a:t>
             </a:r>
             <a:r>
@@ -7165,7 +7124,7 @@
               <a:t>Проширење анализе на више криптовалута </a:t>
             </a:r>
             <a:r>
-              <a:rPr dirty="0" smtClean="0"/>
+              <a:rPr dirty="0"/>
               <a:t>(</a:t>
             </a:r>
             <a:r>
@@ -7177,14 +7136,13 @@
               <a:t>, Solana, </a:t>
             </a:r>
             <a:r>
-              <a:rPr lang="sr-Cyrl-RS" dirty="0" smtClean="0"/>
+              <a:rPr lang="sr-Cyrl-RS" dirty="0"/>
               <a:t>итд</a:t>
             </a:r>
             <a:r>
-              <a:rPr dirty="0" smtClean="0"/>
+              <a:rPr dirty="0"/>
               <a:t>.)</a:t>
             </a:r>
-            <a:endParaRPr dirty="0"/>
           </a:p>
           <a:p>
             <a:pPr>
@@ -7198,50 +7156,37 @@
               </a:defRPr>
             </a:pPr>
             <a:r>
-              <a:rPr dirty="0" smtClean="0"/>
-              <a:t> </a:t>
-            </a:r>
-            <a:r>
-              <a:rPr dirty="0"/>
-              <a:t>Multimodal </a:t>
-            </a:r>
-            <a:r>
-              <a:rPr lang="sr-Cyrl-RS" dirty="0" smtClean="0"/>
-              <a:t>анализа</a:t>
-            </a:r>
-            <a:r>
-              <a:rPr dirty="0" smtClean="0"/>
+              <a:rPr lang="sr-Cyrl-RS" dirty="0"/>
+              <a:t> Мултимодална анализа</a:t>
+            </a:r>
+            <a:r>
+              <a:rPr dirty="0"/>
               <a:t> (</a:t>
             </a:r>
             <a:r>
-              <a:rPr lang="sr-Cyrl-RS" dirty="0" smtClean="0"/>
+              <a:rPr lang="sr-Cyrl-RS" dirty="0"/>
               <a:t>текст</a:t>
             </a:r>
             <a:r>
-              <a:rPr dirty="0" smtClean="0"/>
-              <a:t> </a:t>
-            </a:r>
-            <a:r>
-              <a:rPr dirty="0"/>
-              <a:t>+ </a:t>
-            </a:r>
-            <a:r>
-              <a:rPr lang="sr-Cyrl-RS" dirty="0" smtClean="0"/>
+              <a:rPr dirty="0"/>
+              <a:t> + </a:t>
+            </a:r>
+            <a:r>
+              <a:rPr lang="sr-Cyrl-RS" dirty="0"/>
               <a:t>слике са </a:t>
             </a:r>
             <a:r>
-              <a:rPr dirty="0" smtClean="0"/>
+              <a:rPr dirty="0"/>
               <a:t>Twitter-</a:t>
             </a:r>
             <a:r>
-              <a:rPr lang="sr-Cyrl-RS" dirty="0" smtClean="0"/>
+              <a:rPr lang="sr-Cyrl-RS" dirty="0"/>
               <a:t>а</a:t>
             </a:r>
             <a:r>
-              <a:rPr dirty="0" smtClean="0"/>
+              <a:rPr dirty="0"/>
               <a:t>)</a:t>
             </a:r>
-            <a:endParaRPr dirty="0"/>
           </a:p>
           <a:p>
             <a:pPr>
@@ -7255,32 +7200,24 @@
               </a:defRPr>
             </a:pPr>
             <a:r>
-              <a:rPr dirty="0" smtClean="0"/>
+              <a:rPr dirty="0"/>
               <a:t> </a:t>
             </a:r>
             <a:r>
-              <a:rPr lang="sr-Cyrl-RS" dirty="0" smtClean="0"/>
+              <a:rPr lang="sr-Cyrl-RS" dirty="0"/>
               <a:t>Оптимизација</a:t>
             </a:r>
             <a:r>
-              <a:rPr dirty="0" smtClean="0"/>
-              <a:t> </a:t>
-            </a:r>
-            <a:r>
-              <a:rPr dirty="0"/>
-              <a:t>BERT </a:t>
-            </a:r>
-            <a:r>
-              <a:rPr lang="sr-Cyrl-RS" dirty="0" smtClean="0"/>
+              <a:rPr dirty="0"/>
+              <a:t> BERT </a:t>
+            </a:r>
+            <a:r>
+              <a:rPr lang="sr-Cyrl-RS" dirty="0"/>
               <a:t>модела</a:t>
             </a:r>
             <a:r>
-              <a:rPr dirty="0" smtClean="0"/>
-              <a:t> </a:t>
-            </a:r>
-            <a:r>
-              <a:rPr dirty="0"/>
-              <a:t>(</a:t>
+              <a:rPr dirty="0"/>
+              <a:t> (</a:t>
             </a:r>
             <a:r>
               <a:rPr dirty="0" err="1"/>
@@ -7288,17 +7225,32 @@
             </a:r>
             <a:r>
               <a:rPr dirty="0"/>
-              <a:t>, lightweight </a:t>
-            </a:r>
-            <a:r>
-              <a:rPr lang="sr-Cyrl-RS" dirty="0" smtClean="0"/>
+              <a:t>, </a:t>
+            </a:r>
+            <a:r>
+              <a:rPr lang="sr-Cyrl-RS" dirty="0"/>
+              <a:t>лагане (енгл. </a:t>
+            </a:r>
+            <a:r>
+              <a:rPr dirty="0"/>
+              <a:t>lightweight</a:t>
+            </a:r>
+            <a:r>
+              <a:rPr lang="sr-Cyrl-RS" dirty="0"/>
+              <a:t>)</a:t>
+            </a:r>
+            <a:r>
+              <a:rPr dirty="0"/>
+              <a:t> </a:t>
+            </a:r>
+            <a:r>
+              <a:rPr lang="sr-Cyrl-RS" dirty="0"/>
               <a:t>верзије</a:t>
             </a:r>
             <a:r>
-              <a:rPr dirty="0" smtClean="0"/>
+              <a:rPr dirty="0"/>
               <a:t>)</a:t>
             </a:r>
-            <a:endParaRPr dirty="0"/>
           </a:p>
           <a:p>
             <a:pPr>
@@ -7312,27 +7264,15 @@
               </a:defRPr>
             </a:pPr>
             <a:r>
-              <a:rPr dirty="0" smtClean="0"/>
-              <a:t> </a:t>
-            </a:r>
-            <a:r>
-              <a:rPr dirty="0"/>
-              <a:t>Deploy </a:t>
-            </a:r>
-            <a:r>
-              <a:rPr lang="sr-Cyrl-RS" dirty="0" smtClean="0"/>
-              <a:t>као</a:t>
-            </a:r>
-            <a:r>
-              <a:rPr dirty="0" smtClean="0"/>
-              <a:t> </a:t>
-            </a:r>
-            <a:r>
-              <a:rPr dirty="0"/>
-              <a:t>REST API </a:t>
-            </a:r>
-            <a:r>
-              <a:rPr lang="sr-Cyrl-RS" dirty="0" smtClean="0"/>
+              <a:rPr lang="sr-Cyrl-RS" dirty="0"/>
+              <a:t> Имплементација као</a:t>
+            </a:r>
+            <a:r>
+              <a:rPr dirty="0"/>
+              <a:t> REST API </a:t>
+            </a:r>
+            <a:r>
+              <a:rPr lang="sr-Cyrl-RS" dirty="0"/>
               <a:t>за екстерни приступ</a:t>
             </a:r>
             <a:endParaRPr dirty="0"/>
@@ -7349,24 +7289,12 @@
               </a:defRPr>
             </a:pPr>
             <a:r>
-              <a:rPr dirty="0" smtClean="0"/>
+              <a:rPr dirty="0"/>
               <a:t> </a:t>
             </a:r>
             <a:r>
-              <a:rPr lang="sr-Cyrl-RS" dirty="0" smtClean="0"/>
-              <a:t>Интеграција са </a:t>
-            </a:r>
-            <a:r>
-              <a:rPr dirty="0" smtClean="0"/>
-              <a:t>trading </a:t>
-            </a:r>
-            <a:r>
-              <a:rPr lang="sr-Cyrl-RS" dirty="0"/>
-              <a:t>платформама за аутоматске </a:t>
-            </a:r>
-            <a:r>
-              <a:rPr lang="sr-Cyrl-RS" dirty="0" smtClean="0"/>
-              <a:t>сигнале</a:t>
+              <a:rPr lang="sr-Cyrl-RS" dirty="0"/>
+              <a:t>Интеграција са трејдинг платформама за аутоматске сигнале</a:t>
             </a:r>
           </a:p>
           <a:p>
@@ -7381,41 +7309,36 @@
               </a:defRPr>
             </a:pPr>
             <a:r>
-              <a:rPr dirty="0" smtClean="0"/>
+              <a:rPr dirty="0"/>
               <a:t> </a:t>
             </a:r>
             <a:r>
               <a:rPr lang="ru-RU" dirty="0"/>
-              <a:t>Експерименти са новим </a:t>
-            </a:r>
-            <a:r>
-              <a:rPr lang="en-US" dirty="0" smtClean="0"/>
-              <a:t>transformer</a:t>
-            </a:r>
-            <a:r>
-              <a:rPr lang="ru-RU" dirty="0" smtClean="0"/>
-              <a:t> </a:t>
+              <a:t>Експерименти са новим</a:t>
+            </a:r>
+            <a:r>
+              <a:rPr lang="sr-Cyrl-RS" dirty="0"/>
+              <a:t> трансформер </a:t>
             </a:r>
             <a:r>
               <a:rPr lang="ru-RU" dirty="0"/>
               <a:t>архитектурама </a:t>
             </a:r>
             <a:r>
-              <a:rPr dirty="0" smtClean="0"/>
-              <a:t>(</a:t>
-            </a:r>
-            <a:r>
-              <a:rPr dirty="0"/>
-              <a:t>GPT-4, </a:t>
-            </a:r>
-            <a:r>
-              <a:rPr dirty="0" err="1"/>
-              <a:t>LLaMA</a:t>
-            </a:r>
-            <a:r>
-              <a:rPr dirty="0"/>
+              <a:rPr dirty="0"/>
+              <a:t>(GPT-4, </a:t>
+            </a:r>
+            <a:r>
+              <a:t>L</a:t>
+            </a:r>
+            <a:r>
+              <a:rPr lang="en-US"/>
+              <a:t>lama</a:t>
+            </a:r>
+            <a:r>
               <a:t>)</a:t>
             </a:r>
+            <a:endParaRPr dirty="0"/>
           </a:p>
         </p:txBody>
       </p:sp>
@@ -7424,13 +7347,6 @@
   <p:clrMapOvr>
     <a:masterClrMapping/>
   </p:clrMapOvr>
-  <p:timing>
-    <p:tnLst>
-      <p:par>
-        <p:cTn id="1" dur="indefinite" restart="never" nodeType="tmRoot"/>
-      </p:par>
-    </p:tnLst>
-  </p:timing>
 </p:sld>
 </file>
 
@@ -7525,7 +7441,7 @@
               </a:defRPr>
             </a:pPr>
             <a:r>
-              <a:rPr lang="sr-Cyrl-RS" dirty="0" smtClean="0">
+              <a:rPr lang="sr-Cyrl-RS" dirty="0">
                 <a:solidFill>
                   <a:schemeClr val="accent3">
                     <a:lumMod val="60000"/>
@@ -7576,22 +7492,18 @@
               </a:defRPr>
             </a:pPr>
             <a:r>
-              <a:rPr lang="sr-Cyrl-RS" sz="2000" b="1" dirty="0" smtClean="0"/>
+              <a:rPr lang="sr-Cyrl-RS" sz="2000" b="1" dirty="0"/>
               <a:t>Борис Летић</a:t>
             </a:r>
             <a:r>
-              <a:rPr sz="2000" b="1" dirty="0" smtClean="0"/>
-              <a:t> </a:t>
-            </a:r>
-            <a:r>
               <a:rPr sz="2000" b="1" dirty="0"/>
-              <a:t>| RA 207/2021</a:t>
+              <a:t> | RA 207/2021</a:t>
             </a:r>
             <a:br>
               <a:rPr sz="2000" b="1" dirty="0"/>
             </a:br>
             <a:r>
-              <a:rPr lang="sr-Cyrl-RS" sz="2000" b="1" dirty="0" smtClean="0"/>
+              <a:rPr lang="sr-Cyrl-RS" sz="2000" b="1" dirty="0"/>
               <a:t>Факултет техничких наука, Нови Сад</a:t>
             </a:r>
             <a:endParaRPr sz="2000" b="1" dirty="0"/>
@@ -7621,7 +7533,7 @@
           <a:lstStyle/>
           <a:p>
             <a:r>
-              <a:rPr lang="sr-Cyrl-RS" sz="4000" b="1" dirty="0" smtClean="0">
+              <a:rPr lang="sr-Cyrl-RS" sz="4000" b="1" dirty="0">
                 <a:solidFill>
                   <a:schemeClr val="accent3">
                     <a:lumMod val="60000"/>
@@ -7647,13 +7559,6 @@
   <p:clrMapOvr>
     <a:masterClrMapping/>
   </p:clrMapOvr>
-  <p:timing>
-    <p:tnLst>
-      <p:par>
-        <p:cTn id="1" dur="indefinite" restart="never" nodeType="tmRoot"/>
-      </p:par>
-    </p:tnLst>
-  </p:timing>
 </p:sld>
 </file>
 
@@ -7752,7 +7657,7 @@
               </a:defRPr>
             </a:pPr>
             <a:r>
-              <a:rPr lang="sr-Cyrl-RS" dirty="0" smtClean="0"/>
+              <a:rPr lang="sr-Cyrl-RS" dirty="0"/>
               <a:t>Проблем и мотивација</a:t>
             </a:r>
             <a:endParaRPr dirty="0"/>
@@ -7792,7 +7697,7 @@
               </a:defRPr>
             </a:pPr>
             <a:r>
-              <a:rPr lang="sr-Cyrl-RS" dirty="0" smtClean="0"/>
+              <a:rPr lang="sr-Cyrl-RS" dirty="0"/>
               <a:t>Традиционални приступ анализи јавног мишљења</a:t>
             </a:r>
             <a:endParaRPr dirty="0"/>
@@ -7809,19 +7714,19 @@
               </a:defRPr>
             </a:pPr>
             <a:r>
-              <a:rPr lang="sr-Cyrl-RS" dirty="0" smtClean="0"/>
+              <a:rPr lang="sr-Cyrl-RS" dirty="0"/>
               <a:t>Ручна анализа хиљада твитова </a:t>
             </a:r>
             <a:r>
-              <a:rPr lang="en-US" dirty="0" smtClean="0"/>
+              <a:rPr lang="en-US" dirty="0"/>
               <a:t>–</a:t>
             </a:r>
             <a:r>
-              <a:rPr dirty="0" smtClean="0"/>
+              <a:rPr dirty="0"/>
               <a:t> </a:t>
             </a:r>
             <a:r>
-              <a:rPr lang="sr-Cyrl-RS" dirty="0" smtClean="0"/>
+              <a:rPr lang="sr-Cyrl-RS" dirty="0"/>
               <a:t>немогућа у реалном времену</a:t>
             </a:r>
             <a:endParaRPr dirty="0"/>
@@ -7838,7 +7743,7 @@
               </a:defRPr>
             </a:pPr>
             <a:r>
-              <a:rPr lang="sr-Cyrl-RS" dirty="0" smtClean="0"/>
+              <a:rPr lang="sr-Cyrl-RS" dirty="0"/>
               <a:t>Субјективност људске интерпретације</a:t>
             </a:r>
             <a:endParaRPr dirty="0"/>
@@ -7855,7 +7760,7 @@
               </a:defRPr>
             </a:pPr>
             <a:r>
-              <a:rPr lang="sr-Cyrl-RS" dirty="0" smtClean="0"/>
+              <a:rPr lang="sr-Cyrl-RS" dirty="0"/>
               <a:t>Високи трошкови и време потребно за анализу</a:t>
             </a:r>
             <a:endParaRPr dirty="0"/>
@@ -7872,7 +7777,7 @@
               </a:defRPr>
             </a:pPr>
             <a:r>
-              <a:rPr lang="sr-Cyrl-RS" dirty="0" smtClean="0"/>
+              <a:rPr lang="sr-Cyrl-RS" dirty="0"/>
               <a:t>Недостатак скалабилности</a:t>
             </a:r>
             <a:endParaRPr dirty="0"/>
@@ -7889,7 +7794,7 @@
               </a:defRPr>
             </a:pPr>
             <a:r>
-              <a:rPr lang="sr-Cyrl-RS" dirty="0" smtClean="0"/>
+              <a:rPr lang="sr-Cyrl-RS" dirty="0"/>
               <a:t>Последице</a:t>
             </a:r>
             <a:endParaRPr dirty="0"/>
@@ -7906,14 +7811,13 @@
               </a:defRPr>
             </a:pPr>
             <a:r>
-              <a:rPr lang="sr-Cyrl-RS" dirty="0" smtClean="0"/>
+              <a:rPr lang="sr-Cyrl-RS" dirty="0"/>
               <a:t>Инвеститори и аналитичари не могу ефикасно пратити сентимент крипто заједнице</a:t>
             </a:r>
             <a:r>
-              <a:rPr dirty="0" smtClean="0"/>
+              <a:rPr dirty="0"/>
               <a:t>.</a:t>
             </a:r>
-            <a:endParaRPr dirty="0"/>
           </a:p>
           <a:p>
             <a:pPr>
@@ -7927,14 +7831,13 @@
               </a:defRPr>
             </a:pPr>
             <a:r>
-              <a:rPr lang="sr-Cyrl-RS" dirty="0" smtClean="0"/>
+              <a:rPr lang="sr-Cyrl-RS" dirty="0"/>
               <a:t>Пропуштене инвестиционе прилике због недостатка брзих увида</a:t>
             </a:r>
             <a:r>
-              <a:rPr dirty="0" smtClean="0"/>
+              <a:rPr dirty="0"/>
               <a:t>.</a:t>
             </a:r>
-            <a:endParaRPr dirty="0"/>
           </a:p>
         </p:txBody>
       </p:sp>
@@ -7943,13 +7846,6 @@
   <p:clrMapOvr>
     <a:masterClrMapping/>
   </p:clrMapOvr>
-  <p:timing>
-    <p:tnLst>
-      <p:par>
-        <p:cTn id="1" dur="indefinite" restart="never" nodeType="tmRoot"/>
-      </p:par>
-    </p:tnLst>
-  </p:timing>
 </p:sld>
 </file>
 
@@ -8044,7 +7940,7 @@
               </a:defRPr>
             </a:pPr>
             <a:r>
-              <a:rPr lang="sr-Cyrl-RS" dirty="0" smtClean="0"/>
+              <a:rPr lang="sr-Cyrl-RS" dirty="0"/>
               <a:t>Циљ рада</a:t>
             </a:r>
             <a:endParaRPr dirty="0"/>
@@ -8127,7 +8023,7 @@
               </a:defRPr>
             </a:pPr>
             <a:r>
-              <a:rPr lang="sr-Cyrl-RS" dirty="0" smtClean="0"/>
+              <a:rPr lang="sr-Cyrl-RS" dirty="0"/>
               <a:t>Аутоматска класификација</a:t>
             </a:r>
             <a:endParaRPr dirty="0"/>
@@ -8168,16 +8064,12 @@
               <a:t>Развој система за аутоматску класификацију </a:t>
             </a:r>
             <a:r>
-              <a:rPr lang="en-US" dirty="0" smtClean="0"/>
+              <a:rPr lang="en-US" dirty="0"/>
               <a:t>Twitter</a:t>
             </a:r>
             <a:r>
-              <a:rPr lang="ru-RU" dirty="0" smtClean="0"/>
-              <a:t> </a:t>
-            </a:r>
-            <a:r>
               <a:rPr lang="ru-RU" dirty="0"/>
-              <a:t>сентимента у три категорије: позитиван, негативан и неутралан.</a:t>
+              <a:t> сентимента у три категорије: позитиван, негативан и неутралан.</a:t>
             </a:r>
             <a:endParaRPr dirty="0"/>
           </a:p>
@@ -8263,22 +8155,13 @@
               <a:t>Поређење </a:t>
             </a:r>
             <a:r>
-              <a:rPr lang="en-US" dirty="0" smtClean="0"/>
+              <a:rPr lang="en-US" dirty="0"/>
               <a:t>ML</a:t>
             </a:r>
             <a:r>
-              <a:rPr lang="sr-Cyrl-RS" dirty="0" smtClean="0"/>
-              <a:t> </a:t>
-            </a:r>
-            <a:r>
-              <a:rPr lang="sr-Cyrl-RS" dirty="0"/>
-              <a:t>м</a:t>
-            </a:r>
-            <a:r>
-              <a:rPr lang="sr-Cyrl-RS" dirty="0" smtClean="0"/>
-              <a:t>одела</a:t>
-            </a:r>
-            <a:endParaRPr lang="sr-Cyrl-RS" dirty="0"/>
+              <a:rPr lang="sr-Cyrl-RS" dirty="0"/>
+              <a:t> модела</a:t>
+            </a:r>
           </a:p>
         </p:txBody>
       </p:sp>
@@ -8316,36 +8199,28 @@
               <a:t>Имплементација и евалуација три различита приступа: </a:t>
             </a:r>
             <a:r>
-              <a:rPr lang="en-US" dirty="0" smtClean="0"/>
+              <a:rPr lang="en-US" dirty="0"/>
               <a:t>Naive Bayes</a:t>
             </a:r>
             <a:r>
-              <a:rPr lang="ru-RU" dirty="0" smtClean="0"/>
+              <a:rPr lang="ru-RU" dirty="0"/>
               <a:t>, </a:t>
             </a:r>
             <a:r>
-              <a:rPr lang="en-US" dirty="0" smtClean="0"/>
+              <a:rPr lang="en-US" dirty="0"/>
               <a:t>SVM</a:t>
             </a:r>
             <a:r>
-              <a:rPr lang="ru-RU" dirty="0" smtClean="0"/>
-              <a:t> </a:t>
-            </a:r>
-            <a:r>
               <a:rPr lang="ru-RU" dirty="0"/>
-              <a:t>и </a:t>
-            </a:r>
-            <a:r>
-              <a:rPr lang="en-US" dirty="0" smtClean="0"/>
+              <a:t> и </a:t>
+            </a:r>
+            <a:r>
+              <a:rPr lang="en-US" dirty="0"/>
               <a:t>BERT</a:t>
             </a:r>
             <a:r>
-              <a:rPr lang="ru-RU" dirty="0" smtClean="0"/>
-              <a:t> </a:t>
-            </a:r>
-            <a:r>
               <a:rPr lang="ru-RU" dirty="0"/>
-              <a:t>трансформер модел.</a:t>
+              <a:t> трансформер модел.</a:t>
             </a:r>
             <a:endParaRPr dirty="0"/>
           </a:p>
@@ -8427,7 +8302,7 @@
               </a:defRPr>
             </a:pPr>
             <a:r>
-              <a:rPr lang="sr-Cyrl-RS" dirty="0" smtClean="0"/>
+              <a:rPr lang="sr-Cyrl-RS" dirty="0"/>
               <a:t>Корелациона анализа</a:t>
             </a:r>
             <a:endParaRPr dirty="0"/>
@@ -8468,28 +8343,20 @@
               <a:t>Анализа статистичке повезаности између </a:t>
             </a:r>
             <a:r>
-              <a:rPr lang="en-US" dirty="0" smtClean="0"/>
+              <a:rPr lang="en-US" dirty="0"/>
               <a:t>Twitter</a:t>
             </a:r>
             <a:r>
-              <a:rPr lang="ru-RU" dirty="0" smtClean="0"/>
-              <a:t> </a:t>
-            </a:r>
-            <a:r>
               <a:rPr lang="ru-RU" dirty="0"/>
-              <a:t>сентимента и цене </a:t>
-            </a:r>
-            <a:r>
-              <a:rPr lang="en-US" dirty="0" smtClean="0"/>
+              <a:t> сентимента и цене </a:t>
+            </a:r>
+            <a:r>
+              <a:rPr lang="en-US" dirty="0"/>
               <a:t>Bitcoin</a:t>
             </a:r>
             <a:r>
-              <a:rPr lang="ru-RU" dirty="0" smtClean="0"/>
-              <a:t>-а</a:t>
-            </a:r>
-            <a:r>
               <a:rPr lang="ru-RU" dirty="0"/>
-              <a:t>.</a:t>
+              <a:t>-а.</a:t>
             </a:r>
             <a:endParaRPr dirty="0"/>
           </a:p>
@@ -8500,13 +8367,6 @@
   <p:clrMapOvr>
     <a:masterClrMapping/>
   </p:clrMapOvr>
-  <p:timing>
-    <p:tnLst>
-      <p:par>
-        <p:cTn id="1" dur="indefinite" restart="never" nodeType="tmRoot"/>
-      </p:par>
-    </p:tnLst>
-  </p:timing>
 </p:sld>
 </file>
 
@@ -8601,7 +8461,7 @@
               </a:defRPr>
             </a:pPr>
             <a:r>
-              <a:rPr lang="sr-Cyrl-RS" dirty="0" smtClean="0"/>
+              <a:rPr lang="sr-Cyrl-RS" dirty="0"/>
               <a:t>Анализа сентимента - основе</a:t>
             </a:r>
             <a:endParaRPr dirty="0"/>
@@ -8641,7 +8501,7 @@
               </a:defRPr>
             </a:pPr>
             <a:r>
-              <a:rPr lang="sr-Cyrl-RS" dirty="0" smtClean="0"/>
+              <a:rPr lang="sr-Cyrl-RS" dirty="0"/>
               <a:t>Дефиниција</a:t>
             </a:r>
             <a:endParaRPr dirty="0"/>
@@ -8675,28 +8535,17 @@
             </a:pPr>
             <a:r>
               <a:rPr lang="ru-RU" dirty="0"/>
-              <a:t>Грана </a:t>
-            </a:r>
-            <a:r>
-              <a:rPr lang="en-US" dirty="0" smtClean="0"/>
-              <a:t>Natural Language Processing </a:t>
-            </a:r>
-            <a:r>
-              <a:rPr lang="ru-RU" dirty="0" smtClean="0"/>
-              <a:t>(</a:t>
-            </a:r>
-            <a:r>
-              <a:rPr lang="en-US" dirty="0" smtClean="0"/>
-              <a:t>NLP</a:t>
-            </a:r>
-            <a:r>
-              <a:rPr lang="ru-RU" dirty="0" smtClean="0"/>
-              <a:t>) </a:t>
-            </a:r>
-            <a:r>
-              <a:rPr lang="ru-RU" dirty="0"/>
-              <a:t>технологије</a:t>
-            </a:r>
+              <a:t>Грана обраде природног језика (енгл. </a:t>
+            </a:r>
+            <a:r>
+              <a:rPr lang="en-US" dirty="0"/>
+              <a:t>Natural Language Processing</a:t>
+            </a:r>
+            <a:r>
+              <a:rPr lang="sr-Cyrl-RS" dirty="0"/>
+              <a:t>)</a:t>
+            </a:r>
+            <a:endParaRPr lang="ru-RU" dirty="0"/>
           </a:p>
           <a:p>
             <a:pPr>
@@ -8726,7 +8575,7 @@
               </a:defRPr>
             </a:pPr>
             <a:r>
-              <a:rPr lang="sr-Cyrl-RS" dirty="0" smtClean="0"/>
+              <a:rPr lang="sr-Cyrl-RS" dirty="0"/>
               <a:t>Примена у финансијама</a:t>
             </a:r>
             <a:endParaRPr dirty="0"/>
@@ -8775,17 +8624,22 @@
               </a:defRPr>
             </a:pPr>
             <a:r>
-              <a:rPr lang="en-US" dirty="0" smtClean="0"/>
-              <a:t>Real-Time</a:t>
-            </a:r>
-            <a:r>
-              <a:rPr lang="ru-RU" dirty="0" smtClean="0"/>
-              <a:t> </a:t>
+              <a:rPr lang="sr-Cyrl-RS" dirty="0"/>
+              <a:t>П</a:t>
+            </a:r>
+            <a:r>
+              <a:rPr lang="ru-RU"/>
+              <a:t>раћење </a:t>
             </a:r>
             <a:r>
               <a:rPr lang="ru-RU" dirty="0"/>
-              <a:t>праћење перцепције бренда и производа</a:t>
-            </a:r>
+              <a:t>перцепције бренда </a:t>
+            </a:r>
+            <a:r>
+              <a:rPr lang="ru-RU"/>
+              <a:t>и производа у реалном времену</a:t>
+            </a:r>
+            <a:endParaRPr lang="ru-RU" dirty="0"/>
           </a:p>
         </p:txBody>
       </p:sp>
@@ -8794,13 +8648,6 @@
   <p:clrMapOvr>
     <a:masterClrMapping/>
   </p:clrMapOvr>
-  <p:timing>
-    <p:tnLst>
-      <p:par>
-        <p:cTn id="1" dur="indefinite" restart="never" nodeType="tmRoot"/>
-      </p:par>
-    </p:tnLst>
-  </p:timing>
 </p:sld>
 </file>
 
@@ -8895,7 +8742,7 @@
               </a:defRPr>
             </a:pPr>
             <a:r>
-              <a:rPr lang="sr-Cyrl-RS" dirty="0" smtClean="0"/>
+              <a:rPr lang="sr-Cyrl-RS" dirty="0"/>
               <a:t>Модели машинског учења</a:t>
             </a:r>
             <a:endParaRPr dirty="0"/>
@@ -8992,7 +8839,7 @@
         <p:spPr>
           <a:xfrm>
             <a:off x="640080" y="2743200"/>
-            <a:ext cx="2194560" cy="1123384"/>
+            <a:ext cx="2194560" cy="1323439"/>
           </a:xfrm>
           <a:prstGeom prst="rect">
             <a:avLst/>
@@ -9020,7 +8867,7 @@
               <a:t>• </a:t>
             </a:r>
             <a:r>
-              <a:rPr lang="sr-Cyrl-RS" dirty="0" smtClean="0"/>
+              <a:rPr lang="sr-Cyrl-RS" dirty="0"/>
               <a:t>Пробабилистички приступ</a:t>
             </a:r>
             <a:endParaRPr dirty="0"/>
@@ -9041,7 +8888,7 @@
               <a:t>• TF-IDF </a:t>
             </a:r>
             <a:r>
-              <a:rPr lang="sr-Cyrl-RS" dirty="0" smtClean="0"/>
+              <a:rPr lang="sr-Cyrl-RS" dirty="0"/>
               <a:t>векторизација</a:t>
             </a:r>
             <a:endParaRPr dirty="0"/>
@@ -9062,22 +8909,21 @@
               <a:t>• </a:t>
             </a:r>
             <a:r>
-              <a:rPr lang="sr-Cyrl-RS" dirty="0" smtClean="0"/>
+              <a:rPr lang="sr-Cyrl-RS" dirty="0"/>
               <a:t>Брзо тренирање </a:t>
             </a:r>
             <a:r>
-              <a:rPr dirty="0" smtClean="0"/>
+              <a:rPr dirty="0"/>
               <a:t>(~10</a:t>
             </a:r>
             <a:r>
-              <a:rPr lang="sr-Cyrl-RS" dirty="0" smtClean="0"/>
+              <a:rPr lang="sr-Cyrl-RS" dirty="0"/>
               <a:t>с</a:t>
             </a:r>
             <a:r>
-              <a:rPr dirty="0" smtClean="0"/>
+              <a:rPr dirty="0"/>
               <a:t>)</a:t>
             </a:r>
-            <a:endParaRPr dirty="0"/>
           </a:p>
           <a:p>
             <a:pPr>
@@ -9095,12 +8941,16 @@
               <a:t>• </a:t>
             </a:r>
             <a:r>
-              <a:rPr lang="sr-Cyrl-RS" dirty="0" smtClean="0"/>
+              <a:rPr lang="sr-Cyrl-RS" dirty="0"/>
               <a:t>Добро за </a:t>
             </a:r>
             <a:r>
-              <a:rPr dirty="0" smtClean="0"/>
+              <a:rPr dirty="0"/>
               <a:t>baseline</a:t>
+            </a:r>
+            <a:r>
+              <a:rPr lang="sr-Cyrl-RS" dirty="0"/>
+              <a:t> перформансе</a:t>
             </a:r>
             <a:endParaRPr dirty="0"/>
           </a:p>
@@ -9196,7 +9046,7 @@
         <p:spPr>
           <a:xfrm>
             <a:off x="3566160" y="2743200"/>
-            <a:ext cx="2194560" cy="1123384"/>
+            <a:ext cx="2194560" cy="1323439"/>
           </a:xfrm>
           <a:prstGeom prst="rect">
             <a:avLst/>
@@ -9221,8 +9071,13 @@
             </a:pPr>
             <a:r>
               <a:rPr dirty="0"/>
-              <a:t>• Support Vector Machine</a:t>
-            </a:r>
+              <a:t>• </a:t>
+            </a:r>
+            <a:r>
+              <a:rPr lang="sr-Cyrl-RS" dirty="0"/>
+              <a:t>Метод потпорних вектора</a:t>
+            </a:r>
+            <a:endParaRPr dirty="0"/>
           </a:p>
           <a:p>
             <a:pPr>
@@ -9237,10 +9092,18 @@
             </a:pPr>
             <a:r>
               <a:rPr dirty="0"/>
-              <a:t>• RBF kernel </a:t>
-            </a:r>
-            <a:r>
-              <a:rPr lang="sr-Cyrl-RS" dirty="0" smtClean="0"/>
+              <a:t>• RBF </a:t>
+            </a:r>
+            <a:r>
+              <a:rPr lang="sr-Cyrl-RS" dirty="0"/>
+              <a:t>кернел</a:t>
+            </a:r>
+            <a:r>
+              <a:rPr dirty="0"/>
+              <a:t> </a:t>
+            </a:r>
+            <a:r>
+              <a:rPr lang="sr-Cyrl-RS" dirty="0"/>
               <a:t>функција</a:t>
             </a:r>
             <a:endParaRPr dirty="0"/>
@@ -9261,13 +9124,10 @@
               <a:t>• </a:t>
             </a:r>
             <a:r>
-              <a:rPr dirty="0" err="1"/>
-              <a:t>Hyperparameter</a:t>
-            </a:r>
-            <a:r>
-              <a:rPr dirty="0"/>
-              <a:t> tuning</a:t>
-            </a:r>
+              <a:rPr lang="sr-Cyrl-RS" dirty="0"/>
+              <a:t>Подешавање хиперпараметара</a:t>
+            </a:r>
+            <a:endParaRPr dirty="0"/>
           </a:p>
           <a:p>
             <a:pPr>
@@ -9285,7 +9145,7 @@
               <a:t>• </a:t>
             </a:r>
             <a:r>
-              <a:rPr lang="sr-Cyrl-RS" dirty="0" smtClean="0"/>
+              <a:rPr lang="sr-Cyrl-RS" dirty="0"/>
               <a:t>Висока прецизност</a:t>
             </a:r>
             <a:endParaRPr dirty="0"/>
@@ -9407,10 +9267,18 @@
             </a:pPr>
             <a:r>
               <a:rPr dirty="0"/>
-              <a:t>• Transformer </a:t>
-            </a:r>
-            <a:r>
-              <a:rPr lang="sr-Cyrl-RS" dirty="0" smtClean="0"/>
+              <a:t>• </a:t>
+            </a:r>
+            <a:r>
+              <a:rPr lang="sr-Cyrl-RS" dirty="0"/>
+              <a:t>Трансформер</a:t>
+            </a:r>
+            <a:r>
+              <a:rPr dirty="0"/>
+              <a:t> </a:t>
+            </a:r>
+            <a:r>
+              <a:rPr lang="sr-Cyrl-RS" dirty="0"/>
               <a:t>архитектура</a:t>
             </a:r>
             <a:endParaRPr dirty="0"/>
@@ -9428,10 +9296,18 @@
             </a:pPr>
             <a:r>
               <a:rPr dirty="0"/>
-              <a:t>• Pre-trained </a:t>
-            </a:r>
-            <a:r>
-              <a:rPr lang="sr-Cyrl-RS" dirty="0" smtClean="0"/>
+              <a:t>• </a:t>
+            </a:r>
+            <a:r>
+              <a:rPr lang="sr-Cyrl-RS" dirty="0"/>
+              <a:t>Предобучен</a:t>
+            </a:r>
+            <a:r>
+              <a:rPr dirty="0"/>
+              <a:t> </a:t>
+            </a:r>
+            <a:r>
+              <a:rPr lang="sr-Cyrl-RS" dirty="0"/>
               <a:t>модел</a:t>
             </a:r>
             <a:endParaRPr dirty="0"/>
@@ -9449,10 +9325,18 @@
             </a:pPr>
             <a:r>
               <a:rPr dirty="0"/>
-              <a:t>• Fine-tuning </a:t>
-            </a:r>
-            <a:r>
-              <a:rPr lang="sr-Cyrl-RS" dirty="0" smtClean="0"/>
+              <a:t>• </a:t>
+            </a:r>
+            <a:r>
+              <a:rPr lang="sr-Cyrl-RS" dirty="0"/>
+              <a:t>Фино подешен</a:t>
+            </a:r>
+            <a:r>
+              <a:rPr dirty="0"/>
+              <a:t> </a:t>
+            </a:r>
+            <a:r>
+              <a:rPr lang="sr-Cyrl-RS" dirty="0"/>
               <a:t>приступ</a:t>
             </a:r>
             <a:endParaRPr dirty="0"/>
@@ -9470,10 +9354,18 @@
             </a:pPr>
             <a:r>
               <a:rPr dirty="0"/>
-              <a:t>• State-of-the-art </a:t>
-            </a:r>
-            <a:r>
-              <a:rPr lang="sr-Cyrl-RS" dirty="0" smtClean="0"/>
+              <a:t>• </a:t>
+            </a:r>
+            <a:r>
+              <a:rPr lang="sr-Cyrl-RS" dirty="0"/>
+              <a:t>Изванредни</a:t>
+            </a:r>
+            <a:r>
+              <a:rPr dirty="0"/>
+              <a:t> </a:t>
+            </a:r>
+            <a:r>
+              <a:rPr lang="sr-Cyrl-RS" dirty="0"/>
               <a:t>резултати</a:t>
             </a:r>
             <a:endParaRPr dirty="0"/>
@@ -9485,13 +9377,6 @@
   <p:clrMapOvr>
     <a:masterClrMapping/>
   </p:clrMapOvr>
-  <p:timing>
-    <p:tnLst>
-      <p:par>
-        <p:cTn id="1" dur="indefinite" restart="never" nodeType="tmRoot"/>
-      </p:par>
-    </p:tnLst>
-  </p:timing>
 </p:sld>
 </file>
 
@@ -9565,7 +9450,7 @@
         <p:spPr>
           <a:xfrm>
             <a:off x="457200" y="457200"/>
-            <a:ext cx="4789773" cy="646331"/>
+            <a:ext cx="7189917" cy="646331"/>
           </a:xfrm>
           <a:prstGeom prst="rect">
             <a:avLst/>
@@ -9588,21 +9473,26 @@
               </a:defRPr>
             </a:pPr>
             <a:r>
-              <a:rPr dirty="0"/>
-              <a:t>Dataset </a:t>
-            </a:r>
-            <a:r>
-              <a:rPr lang="sr-Cyrl-RS" dirty="0" smtClean="0"/>
+              <a:rPr lang="sr-Cyrl-RS" dirty="0"/>
+              <a:t>Скуп података</a:t>
+            </a:r>
+            <a:r>
+              <a:rPr dirty="0"/>
+              <a:t> </a:t>
+            </a:r>
+            <a:r>
+              <a:rPr lang="sr-Cyrl-RS" dirty="0"/>
               <a:t>и</a:t>
             </a:r>
             <a:r>
-              <a:rPr dirty="0" smtClean="0"/>
+              <a:rPr dirty="0"/>
               <a:t> </a:t>
             </a:r>
             <a:r>
-              <a:rPr dirty="0"/>
-              <a:t>Preprocessing</a:t>
-            </a:r>
+              <a:rPr lang="sr-Cyrl-RS" dirty="0"/>
+              <a:t>претпроцесирање</a:t>
+            </a:r>
+            <a:endParaRPr dirty="0"/>
           </a:p>
         </p:txBody>
       </p:sp>
@@ -9640,8 +9530,13 @@
             </a:pPr>
             <a:r>
               <a:rPr dirty="0"/>
-              <a:t>Bitcoin Twitter Dataset</a:t>
-            </a:r>
+              <a:t>Bitcoin Twitter </a:t>
+            </a:r>
+            <a:r>
+              <a:rPr lang="sr-Cyrl-RS" dirty="0"/>
+              <a:t>скуп података</a:t>
+            </a:r>
+            <a:endParaRPr dirty="0"/>
           </a:p>
           <a:p>
             <a:pPr>
@@ -9659,15 +9554,15 @@
               <a:t>5,000 </a:t>
             </a:r>
             <a:r>
-              <a:rPr lang="sr-Cyrl-RS" dirty="0" smtClean="0"/>
+              <a:rPr lang="sr-Cyrl-RS" dirty="0"/>
               <a:t>твитова о </a:t>
             </a:r>
             <a:r>
-              <a:rPr dirty="0" smtClean="0"/>
+              <a:rPr dirty="0"/>
               <a:t>Bitcoin-</a:t>
             </a:r>
             <a:r>
-              <a:rPr lang="sr-Cyrl-RS" dirty="0" smtClean="0"/>
+              <a:rPr lang="sr-Cyrl-RS" dirty="0"/>
               <a:t>у</a:t>
             </a:r>
             <a:endParaRPr dirty="0"/>
@@ -9684,16 +9579,20 @@
               </a:defRPr>
             </a:pPr>
             <a:r>
-              <a:rPr lang="sr-Cyrl-RS" dirty="0" smtClean="0"/>
-              <a:t>Ручно анотиран </a:t>
-            </a:r>
-            <a:r>
-              <a:rPr dirty="0" smtClean="0"/>
-              <a:t>dataset </a:t>
-            </a:r>
-            <a:r>
-              <a:rPr dirty="0"/>
-              <a:t>(positive/negative/neutral)</a:t>
+              <a:rPr lang="sr-Cyrl-RS" dirty="0"/>
+              <a:t>Ручно анотиран скуп података</a:t>
+            </a:r>
+            <a:r>
+              <a:rPr dirty="0"/>
+              <a:t> (</a:t>
+            </a:r>
+            <a:r>
+              <a:rPr lang="sr-Cyrl-RS" dirty="0"/>
+              <a:t>позитиван/негативан/неутралан</a:t>
+            </a:r>
+            <a:r>
+              <a:rPr dirty="0"/>
+              <a:t>)</a:t>
             </a:r>
           </a:p>
           <a:p>
@@ -9708,36 +9607,28 @@
               </a:defRPr>
             </a:pPr>
             <a:r>
-              <a:rPr lang="sr-Cyrl-RS" dirty="0" smtClean="0"/>
+              <a:rPr lang="sr-Cyrl-RS" dirty="0"/>
               <a:t>Временски период</a:t>
             </a:r>
             <a:r>
-              <a:rPr dirty="0" smtClean="0"/>
+              <a:rPr dirty="0"/>
               <a:t>: </a:t>
             </a:r>
             <a:r>
-              <a:rPr lang="sr-Cyrl-RS" dirty="0" smtClean="0"/>
+              <a:rPr lang="sr-Cyrl-RS" dirty="0"/>
               <a:t>Јануар</a:t>
             </a:r>
             <a:r>
-              <a:rPr dirty="0" smtClean="0"/>
-              <a:t> </a:t>
-            </a:r>
-            <a:r>
-              <a:rPr dirty="0"/>
-              <a:t>- </a:t>
-            </a:r>
-            <a:r>
-              <a:rPr lang="sr-Cyrl-RS" dirty="0" smtClean="0"/>
+              <a:rPr dirty="0"/>
+              <a:t> - </a:t>
+            </a:r>
+            <a:r>
+              <a:rPr lang="sr-Cyrl-RS" dirty="0"/>
               <a:t>Мај</a:t>
             </a:r>
             <a:r>
-              <a:rPr dirty="0" smtClean="0"/>
-              <a:t> </a:t>
-            </a:r>
-            <a:r>
-              <a:rPr dirty="0"/>
-              <a:t>2024</a:t>
+              <a:rPr dirty="0"/>
+              <a:t> 2024</a:t>
             </a:r>
           </a:p>
           <a:p>
@@ -9752,19 +9643,23 @@
               </a:defRPr>
             </a:pPr>
             <a:r>
-              <a:rPr lang="sr-Cyrl-RS" dirty="0" smtClean="0"/>
+              <a:rPr lang="sr-Cyrl-RS" dirty="0"/>
               <a:t>Балансиран</a:t>
             </a:r>
             <a:r>
-              <a:rPr dirty="0" smtClean="0"/>
+              <a:rPr dirty="0"/>
               <a:t> </a:t>
             </a:r>
             <a:r>
-              <a:rPr dirty="0"/>
-              <a:t>dataset </a:t>
-            </a:r>
-            <a:r>
-              <a:rPr lang="sr-Cyrl-RS" dirty="0" smtClean="0"/>
+              <a:rPr lang="sr-Cyrl-RS" dirty="0"/>
+              <a:t>скуп података</a:t>
+            </a:r>
+            <a:r>
+              <a:rPr dirty="0"/>
+              <a:t> </a:t>
+            </a:r>
+            <a:r>
+              <a:rPr lang="sr-Cyrl-RS" dirty="0"/>
               <a:t>по класама</a:t>
             </a:r>
             <a:endParaRPr dirty="0"/>
@@ -9781,9 +9676,18 @@
               </a:defRPr>
             </a:pPr>
             <a:r>
-              <a:rPr dirty="0"/>
-              <a:t>Text Preprocessing Pipeline</a:t>
-            </a:r>
+              <a:rPr lang="sr-Cyrl-RS" dirty="0"/>
+              <a:t>Проточни систем (енгл. </a:t>
+            </a:r>
+            <a:r>
+              <a:rPr lang="en-US" dirty="0"/>
+              <a:t>pipeline) </a:t>
+            </a:r>
+            <a:r>
+              <a:rPr lang="sr-Cyrl-RS" dirty="0"/>
+              <a:t>претпроцесирања текста</a:t>
+            </a:r>
+            <a:endParaRPr dirty="0"/>
           </a:p>
           <a:p>
             <a:pPr>
@@ -9797,35 +9701,31 @@
               </a:defRPr>
             </a:pPr>
             <a:r>
-              <a:rPr lang="sr-Cyrl-RS" dirty="0" smtClean="0"/>
+              <a:rPr lang="sr-Cyrl-RS" dirty="0"/>
               <a:t>Уклањање</a:t>
             </a:r>
             <a:r>
-              <a:rPr dirty="0" smtClean="0"/>
+              <a:rPr dirty="0"/>
               <a:t> URL-</a:t>
             </a:r>
             <a:r>
-              <a:rPr lang="sr-Cyrl-RS" dirty="0" smtClean="0"/>
+              <a:rPr lang="sr-Cyrl-RS" dirty="0"/>
               <a:t>ова</a:t>
             </a:r>
             <a:r>
-              <a:rPr dirty="0" smtClean="0"/>
-              <a:t>, </a:t>
-            </a:r>
-            <a:r>
-              <a:rPr dirty="0"/>
-              <a:t>mentions (@user) </a:t>
-            </a:r>
-            <a:r>
-              <a:rPr lang="sr-Cyrl-RS" dirty="0" smtClean="0"/>
+              <a:rPr dirty="0"/>
+              <a:t>, mentions (@user) </a:t>
+            </a:r>
+            <a:r>
+              <a:rPr lang="sr-Cyrl-RS" dirty="0"/>
               <a:t>и</a:t>
             </a:r>
             <a:r>
-              <a:rPr dirty="0" smtClean="0"/>
+              <a:rPr dirty="0"/>
               <a:t> hashtag-</a:t>
             </a:r>
             <a:r>
-              <a:rPr lang="sr-Cyrl-RS" dirty="0" smtClean="0"/>
+              <a:rPr lang="sr-Cyrl-RS" dirty="0"/>
               <a:t>ова</a:t>
             </a:r>
             <a:endParaRPr dirty="0"/>
@@ -9846,7 +9746,7 @@
               <a:t>Lowercase </a:t>
             </a:r>
             <a:r>
-              <a:rPr lang="sr-Cyrl-RS" dirty="0" smtClean="0"/>
+              <a:rPr lang="sr-Cyrl-RS" dirty="0"/>
               <a:t>трансформација</a:t>
             </a:r>
             <a:endParaRPr dirty="0"/>
@@ -9863,16 +9763,12 @@
               </a:defRPr>
             </a:pPr>
             <a:r>
-              <a:rPr lang="sr-Cyrl-RS" dirty="0" smtClean="0"/>
+              <a:rPr lang="sr-Cyrl-RS" dirty="0"/>
               <a:t>Токенизација</a:t>
             </a:r>
             <a:r>
-              <a:rPr dirty="0" smtClean="0"/>
-              <a:t> </a:t>
-            </a:r>
-            <a:r>
-              <a:rPr dirty="0"/>
-              <a:t>(NLTK)</a:t>
+              <a:rPr dirty="0"/>
+              <a:t> (NLTK)</a:t>
             </a:r>
           </a:p>
           <a:p>
@@ -9887,9 +9783,22 @@
               </a:defRPr>
             </a:pPr>
             <a:r>
-              <a:rPr dirty="0"/>
-              <a:t>Stop words removal</a:t>
-            </a:r>
+              <a:rPr lang="sr-Cyrl-RS" dirty="0"/>
+              <a:t>Уклањање </a:t>
+            </a:r>
+            <a:r>
+              <a:rPr lang="en-US" dirty="0" err="1"/>
+              <a:t>stop_w</a:t>
+            </a:r>
+            <a:r>
+              <a:rPr dirty="0" err="1"/>
+              <a:t>ords</a:t>
+            </a:r>
+            <a:r>
+              <a:rPr dirty="0"/>
+              <a:t> </a:t>
+            </a:r>
+            <a:endParaRPr lang="en-US" dirty="0"/>
           </a:p>
           <a:p>
             <a:pPr>
@@ -9922,13 +9831,6 @@
   <p:clrMapOvr>
     <a:masterClrMapping/>
   </p:clrMapOvr>
-  <p:timing>
-    <p:tnLst>
-      <p:par>
-        <p:cTn id="1" dur="indefinite" restart="never" nodeType="tmRoot"/>
-      </p:par>
-    </p:tnLst>
-  </p:timing>
 </p:sld>
 </file>
 
@@ -10023,7 +9925,7 @@
               </a:defRPr>
             </a:pPr>
             <a:r>
-              <a:rPr lang="sr-Cyrl-RS" dirty="0" smtClean="0"/>
+              <a:rPr lang="sr-Cyrl-RS" dirty="0"/>
               <a:t>Коришћене технологије</a:t>
             </a:r>
             <a:endParaRPr dirty="0"/>
@@ -10096,7 +9998,7 @@
               </a:defRPr>
             </a:pPr>
             <a:r>
-              <a:rPr lang="sr-Cyrl-RS" dirty="0" smtClean="0"/>
+              <a:rPr lang="sr-Cyrl-RS" dirty="0"/>
               <a:t>Програмски језик</a:t>
             </a:r>
             <a:endParaRPr dirty="0"/>
@@ -10147,7 +10049,7 @@
         <p:spPr>
           <a:xfrm>
             <a:off x="1097280" y="2926079"/>
-            <a:ext cx="3474720" cy="274320"/>
+            <a:ext cx="3227422" cy="307777"/>
           </a:xfrm>
           <a:prstGeom prst="rect">
             <a:avLst/>
@@ -10168,9 +10070,26 @@
               </a:defRPr>
             </a:pPr>
             <a:r>
-              <a:rPr dirty="0"/>
-              <a:t>Deep learning framework</a:t>
-            </a:r>
+              <a:rPr lang="sr-Cyrl-RS" dirty="0"/>
+              <a:t>Оквир </a:t>
+            </a:r>
+            <a:r>
+              <a:rPr lang="de-DE" dirty="0"/>
+              <a:t>(</a:t>
+            </a:r>
+            <a:r>
+              <a:rPr lang="sr-Cyrl-RS" dirty="0"/>
+              <a:t>енгл. </a:t>
+            </a:r>
+            <a:r>
+              <a:rPr lang="en-US" dirty="0"/>
+              <a:t>framework) </a:t>
+            </a:r>
+            <a:r>
+              <a:rPr lang="sr-Cyrl-RS" dirty="0"/>
+              <a:t>дубоког учења</a:t>
+            </a:r>
+            <a:endParaRPr dirty="0"/>
           </a:p>
         </p:txBody>
       </p:sp>
@@ -10243,7 +10162,7 @@
               <a:t>Hugging Face BERT </a:t>
             </a:r>
             <a:r>
-              <a:rPr lang="sr-Cyrl-RS" dirty="0" smtClean="0"/>
+              <a:rPr lang="sr-Cyrl-RS" dirty="0"/>
               <a:t>модели</a:t>
             </a:r>
             <a:endParaRPr dirty="0"/>
@@ -10319,7 +10238,7 @@
               <a:t>Baseline ML </a:t>
             </a:r>
             <a:r>
-              <a:rPr lang="sr-Cyrl-RS" dirty="0" smtClean="0"/>
+              <a:rPr lang="sr-Cyrl-RS" dirty="0"/>
               <a:t>модели</a:t>
             </a:r>
             <a:endParaRPr dirty="0"/>
@@ -10370,7 +10289,7 @@
         <p:spPr>
           <a:xfrm>
             <a:off x="5212080" y="2103120"/>
-            <a:ext cx="3474720" cy="274320"/>
+            <a:ext cx="2145524" cy="307777"/>
           </a:xfrm>
           <a:prstGeom prst="rect">
             <a:avLst/>
@@ -10391,8 +10310,10 @@
               </a:defRPr>
             </a:pPr>
             <a:r>
-              <a:t>Natural Language Processing</a:t>
-            </a:r>
+              <a:rPr lang="sr-Cyrl-RS" dirty="0"/>
+              <a:t>Обрада природног језика</a:t>
+            </a:r>
+            <a:endParaRPr dirty="0"/>
           </a:p>
         </p:txBody>
       </p:sp>
@@ -10440,7 +10361,7 @@
         <p:spPr>
           <a:xfrm>
             <a:off x="5212080" y="2926079"/>
-            <a:ext cx="3474720" cy="274320"/>
+            <a:ext cx="2105513" cy="307777"/>
           </a:xfrm>
           <a:prstGeom prst="rect">
             <a:avLst/>
@@ -10461,8 +10382,10 @@
               </a:defRPr>
             </a:pPr>
             <a:r>
-              <a:t>Data manipulation</a:t>
-            </a:r>
+              <a:rPr lang="sr-Cyrl-RS" dirty="0"/>
+              <a:t>Манипулација подацима</a:t>
+            </a:r>
+            <a:endParaRPr dirty="0"/>
           </a:p>
         </p:txBody>
       </p:sp>
@@ -10531,7 +10454,7 @@
               </a:defRPr>
             </a:pPr>
             <a:r>
-              <a:rPr lang="sr-Cyrl-RS" dirty="0" smtClean="0"/>
+              <a:rPr lang="sr-Cyrl-RS" dirty="0"/>
               <a:t>Визуализације</a:t>
             </a:r>
             <a:endParaRPr dirty="0"/>
@@ -10582,7 +10505,7 @@
         <p:spPr>
           <a:xfrm>
             <a:off x="5212080" y="4572000"/>
-            <a:ext cx="3474720" cy="274320"/>
+            <a:ext cx="2008178" cy="307777"/>
           </a:xfrm>
           <a:prstGeom prst="rect">
             <a:avLst/>
@@ -10603,9 +10526,18 @@
               </a:defRPr>
             </a:pPr>
             <a:r>
-              <a:rPr dirty="0"/>
-              <a:t>Bitcoin price data</a:t>
-            </a:r>
+              <a:rPr lang="sr-Cyrl-RS" dirty="0"/>
+              <a:t>Подаци о цени </a:t>
+            </a:r>
+            <a:r>
+              <a:rPr lang="en-US" dirty="0"/>
+              <a:t>Bitcoin</a:t>
+            </a:r>
+            <a:r>
+              <a:rPr lang="sr-Cyrl-RS" dirty="0"/>
+              <a:t>-а</a:t>
+            </a:r>
+            <a:endParaRPr dirty="0"/>
           </a:p>
         </p:txBody>
       </p:sp>
@@ -10614,13 +10546,6 @@
   <p:clrMapOvr>
     <a:masterClrMapping/>
   </p:clrMapOvr>
-  <p:timing>
-    <p:tnLst>
-      <p:par>
-        <p:cTn id="1" dur="indefinite" restart="never" nodeType="tmRoot"/>
-      </p:par>
-    </p:tnLst>
-  </p:timing>
 </p:sld>
 </file>
 
@@ -10715,7 +10640,7 @@
               </a:defRPr>
             </a:pPr>
             <a:r>
-              <a:rPr lang="sr-Cyrl-RS" dirty="0" smtClean="0"/>
+              <a:rPr lang="sr-Cyrl-RS" dirty="0"/>
               <a:t>Архитектура система</a:t>
             </a:r>
             <a:endParaRPr dirty="0"/>
@@ -10755,9 +10680,10 @@
               </a:defRPr>
             </a:pPr>
             <a:r>
-              <a:rPr dirty="0"/>
-              <a:t>Data Pipeline</a:t>
-            </a:r>
+              <a:rPr lang="sr-Cyrl-RS" dirty="0"/>
+              <a:t>Проточни систем података</a:t>
+            </a:r>
+            <a:endParaRPr dirty="0"/>
           </a:p>
           <a:p>
             <a:pPr>
@@ -10771,18 +10697,29 @@
               </a:defRPr>
             </a:pPr>
             <a:r>
-              <a:rPr dirty="0"/>
-              <a:t>Data Collection → Twitter dataset (5,000 </a:t>
-            </a:r>
-            <a:r>
-              <a:rPr lang="sr-Cyrl-RS" dirty="0" smtClean="0"/>
+              <a:rPr lang="sr-Cyrl-RS" dirty="0"/>
+              <a:t>Прикупљање података </a:t>
+            </a:r>
+            <a:r>
+              <a:rPr dirty="0"/>
+              <a:t>→ Twitter </a:t>
+            </a:r>
+            <a:r>
+              <a:rPr lang="sr-Cyrl-RS" dirty="0"/>
+              <a:t>скуп података</a:t>
+            </a:r>
+            <a:r>
+              <a:rPr dirty="0"/>
+              <a:t> (5,000 </a:t>
+            </a:r>
+            <a:r>
+              <a:rPr lang="sr-Cyrl-RS" dirty="0"/>
               <a:t>твитова</a:t>
             </a:r>
             <a:r>
-              <a:rPr dirty="0" smtClean="0"/>
+              <a:rPr dirty="0"/>
               <a:t>)</a:t>
             </a:r>
-            <a:endParaRPr dirty="0"/>
           </a:p>
           <a:p>
             <a:pPr>
@@ -10796,12 +10733,16 @@
               </a:defRPr>
             </a:pPr>
             <a:r>
-              <a:rPr dirty="0"/>
-              <a:t>Preprocessing → Text cleaning </a:t>
-            </a:r>
-            <a:r>
-              <a:rPr lang="sr-Cyrl-RS" dirty="0" smtClean="0"/>
-              <a:t>и токенизација</a:t>
+              <a:rPr lang="sr-Cyrl-RS" dirty="0"/>
+              <a:t>Претпроцесирање</a:t>
+            </a:r>
+            <a:r>
+              <a:rPr dirty="0"/>
+              <a:t> → </a:t>
+            </a:r>
+            <a:r>
+              <a:rPr lang="sr-Cyrl-RS" dirty="0"/>
+              <a:t>Чишћење текста и токенизација</a:t>
             </a:r>
             <a:endParaRPr dirty="0"/>
           </a:p>
@@ -10817,12 +10758,24 @@
               </a:defRPr>
             </a:pPr>
             <a:r>
-              <a:rPr dirty="0"/>
-              <a:t>Feature Extraction → TF-IDF / BERT </a:t>
-            </a:r>
-            <a:r>
-              <a:rPr dirty="0" err="1"/>
+              <a:rPr lang="sr-Cyrl-RS" dirty="0"/>
+              <a:t>Издвајање карактеристика </a:t>
+            </a:r>
+            <a:r>
+              <a:rPr dirty="0"/>
+              <a:t>→ TF-IDF / BERT </a:t>
+            </a:r>
+            <a:r>
+              <a:rPr lang="sr-Cyrl-RS" dirty="0"/>
+              <a:t>уграђивања (енгл. </a:t>
+            </a:r>
+            <a:r>
+              <a:rPr lang="en-US" dirty="0"/>
               <a:t>embeddings</a:t>
+            </a:r>
+            <a:r>
+              <a:rPr lang="sr-Cyrl-RS" dirty="0"/>
+              <a:t>)</a:t>
             </a:r>
             <a:endParaRPr dirty="0"/>
           </a:p>
@@ -10838,9 +10791,10 @@
               </a:defRPr>
             </a:pPr>
             <a:r>
-              <a:rPr dirty="0"/>
-              <a:t>Model Pipeline</a:t>
-            </a:r>
+              <a:rPr lang="sr-Cyrl-RS" dirty="0"/>
+              <a:t>Проточни систем модела</a:t>
+            </a:r>
+            <a:endParaRPr dirty="0"/>
           </a:p>
           <a:p>
             <a:pPr>
@@ -10855,7 +10809,15 @@
             </a:pPr>
             <a:r>
               <a:rPr dirty="0"/>
-              <a:t>Train/Test Split → 80% / 20%</a:t>
+              <a:t>Train/Test </a:t>
+            </a:r>
+            <a:r>
+              <a:rPr lang="sr-Cyrl-RS" dirty="0"/>
+              <a:t>подела</a:t>
+            </a:r>
+            <a:r>
+              <a:rPr dirty="0"/>
+              <a:t> → 80% / 20%</a:t>
             </a:r>
           </a:p>
           <a:p>
@@ -10870,8 +10832,12 @@
               </a:defRPr>
             </a:pPr>
             <a:r>
-              <a:rPr dirty="0"/>
-              <a:t>Model Training → Naive Bayes, SVM, BERT</a:t>
+              <a:rPr lang="sr-Cyrl-RS" dirty="0"/>
+              <a:t>Обучавање модела</a:t>
+            </a:r>
+            <a:r>
+              <a:rPr dirty="0"/>
+              <a:t> → Naive Bayes, SVM, BERT</a:t>
             </a:r>
           </a:p>
           <a:p>
@@ -10886,12 +10852,12 @@
               </a:defRPr>
             </a:pPr>
             <a:r>
-              <a:rPr dirty="0" err="1"/>
-              <a:t>Hyperparameter</a:t>
-            </a:r>
-            <a:r>
-              <a:rPr dirty="0"/>
-              <a:t> Tuning → </a:t>
+              <a:rPr lang="sr-Cyrl-RS" dirty="0"/>
+              <a:t>Штеловање хиперпараметара </a:t>
+            </a:r>
+            <a:r>
+              <a:rPr dirty="0"/>
+              <a:t>→ </a:t>
             </a:r>
             <a:r>
               <a:rPr dirty="0" err="1"/>
@@ -10899,8 +10865,13 @@
             </a:r>
             <a:r>
               <a:rPr dirty="0"/>
-              <a:t> / Manual tuning</a:t>
-            </a:r>
+              <a:t> / </a:t>
+            </a:r>
+            <a:r>
+              <a:rPr lang="sr-Cyrl-RS" dirty="0"/>
+              <a:t>Ручно штеловање</a:t>
+            </a:r>
+            <a:endParaRPr dirty="0"/>
           </a:p>
           <a:p>
             <a:pPr>
@@ -10914,8 +10885,12 @@
               </a:defRPr>
             </a:pPr>
             <a:r>
-              <a:rPr dirty="0"/>
-              <a:t>Evaluation → Accuracy, Precision, Recall, F1-Score</a:t>
+              <a:rPr lang="sr-Cyrl-RS" dirty="0"/>
+              <a:t>Евалуација</a:t>
+            </a:r>
+            <a:r>
+              <a:rPr dirty="0"/>
+              <a:t> → Accuracy, Precision, Recall, F1-Score</a:t>
             </a:r>
           </a:p>
           <a:p>
@@ -10930,9 +10905,10 @@
               </a:defRPr>
             </a:pPr>
             <a:r>
-              <a:rPr dirty="0"/>
-              <a:t>Analysis Pipeline</a:t>
-            </a:r>
+              <a:rPr lang="sr-Cyrl-RS" dirty="0"/>
+              <a:t>Проточни систем анализе</a:t>
+            </a:r>
+            <a:endParaRPr dirty="0"/>
           </a:p>
           <a:p>
             <a:pPr>
@@ -10946,8 +10922,20 @@
               </a:defRPr>
             </a:pPr>
             <a:r>
-              <a:rPr dirty="0"/>
-              <a:t>Bitcoin Price Data → </a:t>
+              <a:rPr lang="sr-Cyrl-RS" dirty="0"/>
+              <a:t>Подаци о цени </a:t>
+            </a:r>
+            <a:r>
+              <a:rPr lang="en-US" dirty="0"/>
+              <a:t>Bitcoin</a:t>
+            </a:r>
+            <a:r>
+              <a:rPr lang="sr-Cyrl-RS" dirty="0"/>
+              <a:t>-а</a:t>
+            </a:r>
+            <a:r>
+              <a:rPr dirty="0"/>
+              <a:t>→ </a:t>
             </a:r>
             <a:r>
               <a:rPr dirty="0" err="1"/>
@@ -10970,20 +10958,36 @@
               </a:defRPr>
             </a:pPr>
             <a:r>
-              <a:rPr dirty="0"/>
-              <a:t>Sentiment Scoring → -1 (negative) </a:t>
-            </a:r>
-            <a:r>
-              <a:rPr lang="sr-Cyrl-RS" dirty="0" smtClean="0"/>
+              <a:rPr lang="sr-Cyrl-RS" dirty="0"/>
+              <a:t>Бодовање сентимента </a:t>
+            </a:r>
+            <a:r>
+              <a:rPr dirty="0"/>
+              <a:t>→ -1 (</a:t>
+            </a:r>
+            <a:r>
+              <a:rPr lang="sr-Cyrl-RS" dirty="0"/>
+              <a:t>негативан</a:t>
+            </a:r>
+            <a:r>
+              <a:rPr dirty="0"/>
+              <a:t>) </a:t>
+            </a:r>
+            <a:r>
+              <a:rPr lang="sr-Cyrl-RS" dirty="0"/>
               <a:t>до</a:t>
             </a:r>
             <a:r>
-              <a:rPr dirty="0" smtClean="0"/>
-              <a:t> </a:t>
-            </a:r>
-            <a:r>
-              <a:rPr dirty="0"/>
-              <a:t>+1 (positive)</a:t>
+              <a:rPr dirty="0"/>
+              <a:t> +1 (</a:t>
+            </a:r>
+            <a:r>
+              <a:rPr lang="sr-Cyrl-RS" dirty="0"/>
+              <a:t>позитиван</a:t>
+            </a:r>
+            <a:r>
+              <a:rPr dirty="0"/>
+              <a:t>)</a:t>
             </a:r>
           </a:p>
           <a:p>
@@ -10998,9 +11002,18 @@
               </a:defRPr>
             </a:pPr>
             <a:r>
-              <a:rPr dirty="0"/>
-              <a:t>Statistical Analysis → Pearson &amp; Spearman correlation</a:t>
-            </a:r>
+              <a:rPr lang="sr-Cyrl-RS" dirty="0"/>
+              <a:t>Статистичка анализа </a:t>
+            </a:r>
+            <a:r>
+              <a:rPr dirty="0"/>
+              <a:t>→ Pearson &amp; Spearman </a:t>
+            </a:r>
+            <a:r>
+              <a:rPr lang="sr-Cyrl-RS" dirty="0"/>
+              <a:t>корелација</a:t>
+            </a:r>
+            <a:endParaRPr dirty="0"/>
           </a:p>
         </p:txBody>
       </p:sp>
@@ -11009,13 +11022,6 @@
   <p:clrMapOvr>
     <a:masterClrMapping/>
   </p:clrMapOvr>
-  <p:timing>
-    <p:tnLst>
-      <p:par>
-        <p:cTn id="1" dur="indefinite" restart="never" nodeType="tmRoot"/>
-      </p:par>
-    </p:tnLst>
-  </p:timing>
 </p:sld>
 </file>
 
@@ -11110,7 +11116,7 @@
               </a:defRPr>
             </a:pPr>
             <a:r>
-              <a:rPr lang="sr-Cyrl-RS" dirty="0" smtClean="0"/>
+              <a:rPr lang="sr-Cyrl-RS" dirty="0"/>
               <a:t>Процес тренирања модела</a:t>
             </a:r>
             <a:endParaRPr dirty="0"/>
@@ -11150,9 +11156,10 @@
               </a:defRPr>
             </a:pPr>
             <a:r>
-              <a:rPr dirty="0"/>
-              <a:t>Training Setup</a:t>
-            </a:r>
+              <a:rPr lang="sr-Cyrl-RS" dirty="0"/>
+              <a:t>Подешавање обуке</a:t>
+            </a:r>
+            <a:endParaRPr dirty="0"/>
           </a:p>
           <a:p>
             <a:pPr>
@@ -11167,17 +11174,24 @@
             </a:pPr>
             <a:r>
               <a:rPr dirty="0"/>
-              <a:t>80/20 Train-Test Split (4,000 / 1,000 </a:t>
-            </a:r>
-            <a:r>
-              <a:rPr lang="sr-Cyrl-RS" dirty="0" smtClean="0"/>
+              <a:t>80/20 Train-Test </a:t>
+            </a:r>
+            <a:r>
+              <a:rPr lang="sr-Cyrl-RS" dirty="0"/>
+              <a:t>подела</a:t>
+            </a:r>
+            <a:r>
+              <a:rPr dirty="0"/>
+              <a:t> (4,000 / 1,000 </a:t>
+            </a:r>
+            <a:r>
+              <a:rPr lang="sr-Cyrl-RS" dirty="0"/>
               <a:t>твитова</a:t>
             </a:r>
             <a:r>
-              <a:rPr dirty="0" smtClean="0"/>
+              <a:rPr dirty="0"/>
               <a:t>)</a:t>
             </a:r>
-            <a:endParaRPr dirty="0"/>
           </a:p>
           <a:p>
             <a:pPr>
@@ -11191,11 +11205,23 @@
               </a:defRPr>
             </a:pPr>
             <a:r>
-              <a:rPr dirty="0"/>
-              <a:t>5-Fold Cross Validation </a:t>
-            </a:r>
-            <a:r>
-              <a:rPr lang="sr-Cyrl-RS" dirty="0" smtClean="0"/>
+              <a:rPr lang="sr-Cyrl-RS" dirty="0"/>
+              <a:t>Петострука унакрсна валидација (енгл. </a:t>
+            </a:r>
+            <a:r>
+              <a:rPr lang="en-US" dirty="0"/>
+              <a:t>5-fold Cross-Validation</a:t>
+            </a:r>
+            <a:r>
+              <a:rPr lang="sr-Cyrl-RS" dirty="0"/>
+              <a:t>)</a:t>
+            </a:r>
+            <a:r>
+              <a:rPr lang="en-US" dirty="0"/>
+              <a:t> </a:t>
+            </a:r>
+            <a:r>
+              <a:rPr lang="sr-Cyrl-RS" dirty="0"/>
               <a:t>за све моделе</a:t>
             </a:r>
             <a:endParaRPr dirty="0"/>
@@ -11212,8 +11238,12 @@
               </a:defRPr>
             </a:pPr>
             <a:r>
-              <a:rPr dirty="0"/>
-              <a:t>GPU Acceleration: NVIDIA RTX 4060 (8GB VRAM)</a:t>
+              <a:rPr lang="sr-Cyrl-RS" dirty="0"/>
+              <a:t>Убрзање графичке картице</a:t>
+            </a:r>
+            <a:r>
+              <a:rPr dirty="0"/>
+              <a:t>: NVIDIA RTX 4060 (8GB VRAM)</a:t>
             </a:r>
           </a:p>
           <a:p>
@@ -11244,12 +11274,16 @@
               </a:defRPr>
             </a:pPr>
             <a:r>
-              <a:rPr dirty="0"/>
-              <a:t>BERT Fine-Tuning </a:t>
-            </a:r>
-            <a:r>
-              <a:rPr lang="sr-Cyrl-RS" dirty="0" smtClean="0"/>
-              <a:t>специфичности</a:t>
+              <a:rPr lang="sr-Cyrl-RS" dirty="0"/>
+              <a:t>Специфичности финог подешавања </a:t>
+            </a:r>
+            <a:r>
+              <a:rPr lang="en-US" dirty="0"/>
+              <a:t>BERT</a:t>
+            </a:r>
+            <a:r>
+              <a:rPr lang="sr-Cyrl-RS" dirty="0"/>
+              <a:t> модела</a:t>
             </a:r>
             <a:endParaRPr dirty="0"/>
           </a:p>
@@ -11265,8 +11299,12 @@
               </a:defRPr>
             </a:pPr>
             <a:r>
-              <a:rPr dirty="0"/>
-              <a:t>Pre-trained model: </a:t>
+              <a:rPr lang="sr-Cyrl-RS" dirty="0"/>
+              <a:t>Предобучен модел</a:t>
+            </a:r>
+            <a:r>
+              <a:rPr dirty="0"/>
+              <a:t>: </a:t>
             </a:r>
             <a:r>
               <a:rPr dirty="0" err="1"/>
@@ -11353,13 +11391,6 @@
   <p:clrMapOvr>
     <a:masterClrMapping/>
   </p:clrMapOvr>
-  <p:timing>
-    <p:tnLst>
-      <p:par>
-        <p:cTn id="1" dur="indefinite" restart="never" nodeType="tmRoot"/>
-      </p:par>
-    </p:tnLst>
-  </p:timing>
 </p:sld>
 </file>
 

</xml_diff>